<commit_message>
Update OER textbook and complete reusable teaching collection
</commit_message>
<xml_diff>
--- a/course_materials/weeks/week_01/week_01_responsibility_relational_thinking.pptx
+++ b/course_materials/weeks/week_01/week_01_responsibility_relational_thinking.pptx
@@ -1443,7 +1443,7 @@
           </a:p>
           <a:p xmlns:a="http://schemas.openxmlformats.org/drawingml/2006/main">
             <a:r>
-              <a:t>Next week provides a substantial SQL review. We will write filters, work carefully with NULL, compare inner and outer joins, and construct summaries whose counts mean what we intend. We will also practice changing data inside a transaction and rolling the practice change back. The weekly guide identifies the assigned reading. Read Chapter 1 and the opening relational-model sections of Chapter 2 in the textbook PDF. The weekly guide also links optional PostgreSQL readings for another explanation of these ideas.</a:t>
+              <a:t>Next week provides a substantial SQL review. We will write filters, work carefully with NULL, compare inner and outer joins, and construct summaries whose counts mean what we intend. We will also practice changing data inside a transaction and rolling the practice change back. The weekly guide identifies the assigned reading. In the complete course package that includes the relevant sections of our textbook. The Week 1-only package provides free PostgreSQL readings without requiring access to the unpublished book.</a:t>
             </a:r>
           </a:p>
           <a:p xmlns:a="http://schemas.openxmlformats.org/drawingml/2006/main">
@@ -16556,1514 +16556,1514 @@
 </file>
 
 <file path=ppt/slides/slide5.xml><?xml version="1.0" encoding="utf-8"?>
-<p:sld xmlns:p="http://schemas.openxmlformats.org/presentationml/2006/main">
-  <p:cSld>
-    <p:bg>
-      <p:bgPr>
-        <a:solidFill xmlns:a="http://schemas.openxmlformats.org/drawingml/2006/main">
-          <a:srgbClr val="F7F3EA"/>
-        </a:solidFill>
-      </p:bgPr>
-    </p:bg>
-    <p:spTree>
-      <p:nvGrpSpPr>
-        <p:cNvPr id="1" name=""/>
-        <p:cNvGrpSpPr/>
-        <p:nvPr/>
-      </p:nvGrpSpPr>
-      <p:grpSpPr>
-        <a:xfrm xmlns:a="http://schemas.openxmlformats.org/drawingml/2006/main"/>
-      </p:grpSpPr>
-      <p:sp>
-        <p:nvSpPr>
-          <p:cNvPr id="15" name="">
-            <a:extLst xmlns:a="http://schemas.openxmlformats.org/drawingml/2006/main">
-              <a:ext uri="{FF2B5EF4-FFF2-40B4-BE49-F238E27FC236}">
-                <a16:creationId xmlns:a16="http://schemas.microsoft.com/office/drawing/2014/main" id="{ECE5B4E2-067F-4DCA-8105-FE99E439C22C}"/>
-              </a:ext>
-            </a:extLst>
-          </p:cNvPr>
-          <p:cNvSpPr>
-            <a:spLocks xmlns:a="http://schemas.openxmlformats.org/drawingml/2006/main" noGrp="1"/>
-          </p:cNvSpPr>
-          <p:nvPr/>
-        </p:nvSpPr>
-        <p:spPr>
-          <a:xfrm xmlns:a="http://schemas.openxmlformats.org/drawingml/2006/main">
-            <a:off x="552450" y="400050"/>
-            <a:ext cx="1447800" cy="323850"/>
-          </a:xfrm>
-          <a:prstGeom xmlns:a="http://schemas.openxmlformats.org/drawingml/2006/main" prst="roundRect">
-            <a:avLst>
-              <a:gd name="adj" fmla="val 50000"/>
-            </a:avLst>
-          </a:prstGeom>
-          <a:solidFill xmlns:a="http://schemas.openxmlformats.org/drawingml/2006/main">
-            <a:srgbClr val="14213D"/>
-          </a:solidFill>
-          <a:ln xmlns:a="http://schemas.openxmlformats.org/drawingml/2006/main" w="9525">
-            <a:solidFill>
-              <a:srgbClr val="14213D"/>
-            </a:solidFill>
-            <a:prstDash val="solid"/>
-          </a:ln>
-        </p:spPr>
-        <p:txBody>
-          <a:bodyPr xmlns:a="http://schemas.openxmlformats.org/drawingml/2006/main" lIns="76200" tIns="0" rIns="76200" bIns="0" anchor="ctr">
-            <a:normAutofit fontScale="96996"/>
-          </a:bodyPr>
-          <a:lstStyle xmlns:a="http://schemas.openxmlformats.org/drawingml/2006/main"/>
-          <a:p xmlns:a="http://schemas.openxmlformats.org/drawingml/2006/main">
-            <a:pPr algn="ctr">
-              <a:buNone/>
-              <a:defRPr sz="1050" b="1">
-                <a:solidFill>
-                  <a:srgbClr val="FFFFFF"/>
-                </a:solidFill>
-                <a:latin typeface="Avenir Next"/>
-                <a:ea typeface="Avenir Next"/>
-                <a:cs typeface="Avenir Next"/>
-              </a:defRPr>
-            </a:pPr>
-            <a:r>
-              <a:rPr sz="1050" b="1">
-                <a:solidFill>
-                  <a:srgbClr val="FFFFFF"/>
-                </a:solidFill>
-                <a:latin typeface="Avenir Next"/>
-                <a:ea typeface="Avenir Next"/>
-                <a:cs typeface="Avenir Next"/>
-              </a:rPr>
-              <a:t>CLOUD INTERFACE</a:t>
-            </a:r>
-          </a:p>
-        </p:txBody>
-      </p:sp>
-      <p:sp>
-        <p:nvSpPr>
-          <p:cNvPr id="2" name="slide-title">
-            <a:extLst xmlns:a="http://schemas.openxmlformats.org/drawingml/2006/main">
-              <a:ext uri="{FF2B5EF4-FFF2-40B4-BE49-F238E27FC236}">
-                <a16:creationId xmlns:a16="http://schemas.microsoft.com/office/drawing/2014/main" id="{4EE0B915-1960-47EC-9286-DC4133E09536}"/>
-              </a:ext>
-            </a:extLst>
-          </p:cNvPr>
-          <p:cNvSpPr>
-            <a:spLocks xmlns:a="http://schemas.openxmlformats.org/drawingml/2006/main" noGrp="1"/>
-          </p:cNvSpPr>
-          <p:nvPr/>
-        </p:nvSpPr>
-        <p:spPr>
-          <a:xfrm xmlns:a="http://schemas.openxmlformats.org/drawingml/2006/main">
-            <a:off x="552450" y="876300"/>
-            <a:ext cx="11087100" cy="704850"/>
-          </a:xfrm>
-          <a:prstGeom xmlns:a="http://schemas.openxmlformats.org/drawingml/2006/main" prst="rect">
-            <a:avLst/>
-          </a:prstGeom>
-          <a:noFill xmlns:a="http://schemas.openxmlformats.org/drawingml/2006/main"/>
-          <a:ln xmlns:a="http://schemas.openxmlformats.org/drawingml/2006/main" w="0">
-            <a:noFill/>
-            <a:prstDash val="solid"/>
-          </a:ln>
-        </p:spPr>
-        <p:txBody>
-          <a:bodyPr xmlns:a="http://schemas.openxmlformats.org/drawingml/2006/main" lIns="0" tIns="0" rIns="0" bIns="0" anchor="t">
-            <a:normAutofit fontScale="100000"/>
-          </a:bodyPr>
-          <a:lstStyle xmlns:a="http://schemas.openxmlformats.org/drawingml/2006/main"/>
-          <a:p xmlns:a="http://schemas.openxmlformats.org/drawingml/2006/main">
-            <a:pPr>
-              <a:lnSpc>
-                <a:spcPct val="95000"/>
-              </a:lnSpc>
-              <a:buNone/>
-              <a:defRPr sz="3000" b="1">
-                <a:solidFill>
-                  <a:srgbClr val="14213D"/>
-                </a:solidFill>
-                <a:latin typeface="Georgia"/>
-                <a:ea typeface="Georgia"/>
-                <a:cs typeface="Georgia"/>
-              </a:defRPr>
-            </a:pPr>
-            <a:r>
-              <a:rPr sz="3000" b="1">
-                <a:solidFill>
-                  <a:srgbClr val="14213D"/>
-                </a:solidFill>
-                <a:latin typeface="Georgia"/>
-                <a:ea typeface="Georgia"/>
-                <a:cs typeface="Georgia"/>
-              </a:rPr>
-              <a:t>Supabase is a platform built around PostgreSQL</a:t>
-            </a:r>
-          </a:p>
-        </p:txBody>
-      </p:sp>
-      <p:sp>
-        <p:nvSpPr>
-          <p:cNvPr id="3" name="">
-            <a:extLst xmlns:a="http://schemas.openxmlformats.org/drawingml/2006/main">
-              <a:ext uri="{FF2B5EF4-FFF2-40B4-BE49-F238E27FC236}">
-                <a16:creationId xmlns:a16="http://schemas.microsoft.com/office/drawing/2014/main" id="{9C69D724-C471-40F9-BE5A-7CF3D5C1EC8C}"/>
-              </a:ext>
-            </a:extLst>
-          </p:cNvPr>
-          <p:cNvSpPr>
-            <a:spLocks xmlns:a="http://schemas.openxmlformats.org/drawingml/2006/main" noGrp="1"/>
-          </p:cNvSpPr>
-          <p:nvPr/>
-        </p:nvSpPr>
-        <p:spPr>
-          <a:xfrm xmlns:a="http://schemas.openxmlformats.org/drawingml/2006/main">
-            <a:off x="571500" y="1562100"/>
-            <a:ext cx="10477500" cy="381000"/>
-          </a:xfrm>
-          <a:prstGeom xmlns:a="http://schemas.openxmlformats.org/drawingml/2006/main" prst="rect">
-            <a:avLst/>
-          </a:prstGeom>
-          <a:noFill xmlns:a="http://schemas.openxmlformats.org/drawingml/2006/main"/>
-          <a:ln xmlns:a="http://schemas.openxmlformats.org/drawingml/2006/main" w="0">
-            <a:noFill/>
-            <a:prstDash val="solid"/>
-          </a:ln>
-        </p:spPr>
-        <p:txBody>
-          <a:bodyPr xmlns:a="http://schemas.openxmlformats.org/drawingml/2006/main" lIns="0" tIns="0" rIns="0" bIns="0" anchor="t">
-            <a:normAutofit fontScale="100000"/>
-          </a:bodyPr>
-          <a:lstStyle xmlns:a="http://schemas.openxmlformats.org/drawingml/2006/main"/>
-          <a:p xmlns:a="http://schemas.openxmlformats.org/drawingml/2006/main">
-            <a:pPr>
-              <a:buNone/>
-              <a:defRPr sz="1425">
-                <a:solidFill>
-                  <a:srgbClr val="5C6577"/>
-                </a:solidFill>
-                <a:latin typeface="Avenir Next"/>
-                <a:ea typeface="Avenir Next"/>
-                <a:cs typeface="Avenir Next"/>
-              </a:defRPr>
-            </a:pPr>
-            <a:r>
-              <a:rPr sz="1425">
-                <a:solidFill>
-                  <a:srgbClr val="5C6577"/>
-                </a:solidFill>
-                <a:latin typeface="Avenir Next"/>
-                <a:ea typeface="Avenir Next"/>
-                <a:cs typeface="Avenir Next"/>
-              </a:rPr>
-              <a:t>The dashboard exposes projects and services; PostgreSQL remains the database engine.</a:t>
-            </a:r>
-          </a:p>
-        </p:txBody>
-      </p:sp>
-      <p:sp>
-        <p:nvSpPr>
-          <p:cNvPr id="4" name="">
-            <a:extLst xmlns:a="http://schemas.openxmlformats.org/drawingml/2006/main">
-              <a:ext uri="{FF2B5EF4-FFF2-40B4-BE49-F238E27FC236}">
-                <a16:creationId xmlns:a16="http://schemas.microsoft.com/office/drawing/2014/main" id="{EC90CB12-698B-49BA-8F98-BAD9E65B7181}"/>
-              </a:ext>
-            </a:extLst>
-          </p:cNvPr>
-          <p:cNvSpPr>
-            <a:spLocks xmlns:a="http://schemas.openxmlformats.org/drawingml/2006/main" noGrp="1"/>
-          </p:cNvSpPr>
-          <p:nvPr/>
-        </p:nvSpPr>
-        <p:spPr>
-          <a:xfrm xmlns:a="http://schemas.openxmlformats.org/drawingml/2006/main">
-            <a:off x="11144250" y="6334125"/>
-            <a:ext cx="495300" cy="228600"/>
-          </a:xfrm>
-          <a:prstGeom xmlns:a="http://schemas.openxmlformats.org/drawingml/2006/main" prst="rect">
-            <a:avLst/>
-          </a:prstGeom>
-          <a:noFill xmlns:a="http://schemas.openxmlformats.org/drawingml/2006/main"/>
-          <a:ln xmlns:a="http://schemas.openxmlformats.org/drawingml/2006/main" w="0">
-            <a:noFill/>
-            <a:prstDash val="solid"/>
-          </a:ln>
-        </p:spPr>
-        <p:txBody>
-          <a:bodyPr xmlns:a="http://schemas.openxmlformats.org/drawingml/2006/main" wrap="square" lIns="0" tIns="0" rIns="0" bIns="0" anchor="t">
-            <a:noAutofit/>
-          </a:bodyPr>
-          <a:lstStyle xmlns:a="http://schemas.openxmlformats.org/drawingml/2006/main"/>
-          <a:p xmlns:a="http://schemas.openxmlformats.org/drawingml/2006/main">
-            <a:pPr algn="r">
-              <a:buNone/>
-              <a:defRPr sz="1050" b="1">
-                <a:solidFill>
-                  <a:srgbClr val="5C6577"/>
-                </a:solidFill>
-                <a:latin typeface="Menlo"/>
-                <a:ea typeface="Menlo"/>
-                <a:cs typeface="Menlo"/>
-              </a:defRPr>
-            </a:pPr>
-            <a:r>
-              <a:rPr sz="1050" b="1">
-                <a:solidFill>
-                  <a:srgbClr val="5C6577"/>
-                </a:solidFill>
-                <a:latin typeface="Menlo"/>
-                <a:ea typeface="Menlo"/>
-                <a:cs typeface="Menlo"/>
-              </a:rPr>
-              <a:t>05</a:t>
-            </a:r>
-          </a:p>
-        </p:txBody>
-      </p:sp>
-      <p:sp>
-        <p:nvSpPr>
-          <p:cNvPr id="5" name="">
-            <a:extLst xmlns:a="http://schemas.openxmlformats.org/drawingml/2006/main">
-              <a:ext uri="{FF2B5EF4-FFF2-40B4-BE49-F238E27FC236}">
-                <a16:creationId xmlns:a16="http://schemas.microsoft.com/office/drawing/2014/main" id="{A420DB7B-3F95-4CE2-B782-695A52096B0F}"/>
-              </a:ext>
-            </a:extLst>
-          </p:cNvPr>
-          <p:cNvSpPr>
-            <a:spLocks xmlns:a="http://schemas.openxmlformats.org/drawingml/2006/main" noGrp="1"/>
-          </p:cNvSpPr>
-          <p:nvPr/>
-        </p:nvSpPr>
-        <p:spPr>
-          <a:xfrm xmlns:a="http://schemas.openxmlformats.org/drawingml/2006/main">
-            <a:off x="552450" y="2038350"/>
-            <a:ext cx="5810250" cy="4095750"/>
-          </a:xfrm>
-          <a:prstGeom xmlns:a="http://schemas.openxmlformats.org/drawingml/2006/main" prst="roundRect">
-            <a:avLst>
-              <a:gd name="adj" fmla="val 4186"/>
-            </a:avLst>
-          </a:prstGeom>
-          <a:solidFill xmlns:a="http://schemas.openxmlformats.org/drawingml/2006/main">
-            <a:srgbClr val="FFFFFF"/>
-          </a:solidFill>
-          <a:ln xmlns:a="http://schemas.openxmlformats.org/drawingml/2006/main" w="9525">
-            <a:solidFill>
-              <a:srgbClr val="E9E4D8"/>
-            </a:solidFill>
-            <a:prstDash val="solid"/>
-          </a:ln>
-        </p:spPr>
-      </p:sp>
-      <p:pic>
-        <p:nvPicPr>
-          <p:cNvPr id="22" name=""/>
-          <p:cNvPicPr>
-            <a:picLocks xmlns:a="http://schemas.openxmlformats.org/drawingml/2006/main" noChangeAspect="1"/>
-          </p:cNvPicPr>
-          <p:nvPr/>
-        </p:nvPicPr>
-        <p:blipFill>
-          <a:blip xmlns:r="http://schemas.openxmlformats.org/officeDocument/2006/relationships" xmlns:a="http://schemas.openxmlformats.org/drawingml/2006/main" r:embed="Ra9a661b4d442464f"/>
-          <a:srcRect xmlns:a="http://schemas.openxmlformats.org/drawingml/2006/main" l="0" t="21016" r="0" b="21016"/>
-          <a:stretch xmlns:a="http://schemas.openxmlformats.org/drawingml/2006/main">
-            <a:fillRect l="0" t="0" r="0" b="0"/>
-          </a:stretch>
-        </p:blipFill>
-        <p:spPr>
-          <a:xfrm xmlns:a="http://schemas.openxmlformats.org/drawingml/2006/main">
-            <a:off x="714375" y="2181225"/>
-            <a:ext cx="5486400" cy="3810000"/>
-          </a:xfrm>
-          <a:prstGeom xmlns:a="http://schemas.openxmlformats.org/drawingml/2006/main" prst="roundRect">
-            <a:avLst>
-              <a:gd name="adj" fmla="val 3000"/>
-            </a:avLst>
-          </a:prstGeom>
-        </p:spPr>
-      </p:pic>
-      <p:sp>
-        <p:nvSpPr>
-          <p:cNvPr id="7" name="">
-            <a:extLst xmlns:a="http://schemas.openxmlformats.org/drawingml/2006/main">
-              <a:ext uri="{FF2B5EF4-FFF2-40B4-BE49-F238E27FC236}">
-                <a16:creationId xmlns:a16="http://schemas.microsoft.com/office/drawing/2014/main" id="{2E7E305D-5ADE-42FC-9B30-AD0427C6DC83}"/>
-              </a:ext>
-            </a:extLst>
-          </p:cNvPr>
-          <p:cNvSpPr>
-            <a:spLocks xmlns:a="http://schemas.openxmlformats.org/drawingml/2006/main" noGrp="1"/>
-          </p:cNvSpPr>
-          <p:nvPr/>
-        </p:nvSpPr>
-        <p:spPr>
-          <a:xfrm xmlns:a="http://schemas.openxmlformats.org/drawingml/2006/main">
-            <a:off x="6762750" y="2143125"/>
-            <a:ext cx="4876800" cy="1619250"/>
-          </a:xfrm>
-          <a:prstGeom xmlns:a="http://schemas.openxmlformats.org/drawingml/2006/main" prst="roundRect">
-            <a:avLst>
-              <a:gd name="adj" fmla="val 10588"/>
-            </a:avLst>
-          </a:prstGeom>
-          <a:solidFill xmlns:a="http://schemas.openxmlformats.org/drawingml/2006/main">
-            <a:srgbClr val="F4F8FF"/>
-          </a:solidFill>
-          <a:ln xmlns:a="http://schemas.openxmlformats.org/drawingml/2006/main" w="9525">
-            <a:solidFill>
-              <a:srgbClr val="E9E4D8"/>
-            </a:solidFill>
-            <a:prstDash val="solid"/>
-          </a:ln>
-        </p:spPr>
-        <p:style>
-          <a:lnRef xmlns:a="http://schemas.openxmlformats.org/drawingml/2006/main" idx="0"/>
-          <a:fillRef xmlns:a="http://schemas.openxmlformats.org/drawingml/2006/main" idx="0"/>
-          <a:effectRef xmlns:a="http://schemas.openxmlformats.org/drawingml/2006/main" idx="4"/>
-          <a:fontRef xmlns:a="http://schemas.openxmlformats.org/drawingml/2006/main" idx="major"/>
-        </p:style>
-      </p:sp>
-      <p:sp>
-        <p:nvSpPr>
-          <p:cNvPr id="8" name="">
-            <a:extLst xmlns:a="http://schemas.openxmlformats.org/drawingml/2006/main">
-              <a:ext uri="{FF2B5EF4-FFF2-40B4-BE49-F238E27FC236}">
-                <a16:creationId xmlns:a16="http://schemas.microsoft.com/office/drawing/2014/main" id="{A2DC7162-A4DE-4D19-AF39-7A86DC8D6B78}"/>
-              </a:ext>
-            </a:extLst>
-          </p:cNvPr>
-          <p:cNvSpPr>
-            <a:spLocks xmlns:a="http://schemas.openxmlformats.org/drawingml/2006/main" noGrp="1"/>
-          </p:cNvSpPr>
-          <p:nvPr/>
-        </p:nvSpPr>
-        <p:spPr>
-          <a:xfrm xmlns:a="http://schemas.openxmlformats.org/drawingml/2006/main">
-            <a:off x="6762750" y="2143125"/>
-            <a:ext cx="76200" cy="1619250"/>
-          </a:xfrm>
-          <a:prstGeom xmlns:a="http://schemas.openxmlformats.org/drawingml/2006/main" prst="rect">
-            <a:avLst/>
-          </a:prstGeom>
-          <a:solidFill xmlns:a="http://schemas.openxmlformats.org/drawingml/2006/main">
-            <a:srgbClr val="0B5FFF"/>
-          </a:solidFill>
-          <a:ln xmlns:a="http://schemas.openxmlformats.org/drawingml/2006/main" w="0">
-            <a:solidFill>
-              <a:srgbClr val="0B5FFF"/>
-            </a:solidFill>
-            <a:prstDash val="solid"/>
-          </a:ln>
-        </p:spPr>
-      </p:sp>
-      <p:sp>
-        <p:nvSpPr>
-          <p:cNvPr id="9" name="">
-            <a:extLst xmlns:a="http://schemas.openxmlformats.org/drawingml/2006/main">
-              <a:ext uri="{FF2B5EF4-FFF2-40B4-BE49-F238E27FC236}">
-                <a16:creationId xmlns:a16="http://schemas.microsoft.com/office/drawing/2014/main" id="{44E97D5F-4372-4193-A08D-E443E636BCC3}"/>
-              </a:ext>
-            </a:extLst>
-          </p:cNvPr>
-          <p:cNvSpPr>
-            <a:spLocks xmlns:a="http://schemas.openxmlformats.org/drawingml/2006/main" noGrp="1"/>
-          </p:cNvSpPr>
-          <p:nvPr/>
-        </p:nvSpPr>
-        <p:spPr>
-          <a:xfrm xmlns:a="http://schemas.openxmlformats.org/drawingml/2006/main">
-            <a:off x="7010400" y="2333625"/>
-            <a:ext cx="4419600" cy="361950"/>
-          </a:xfrm>
-          <a:prstGeom xmlns:a="http://schemas.openxmlformats.org/drawingml/2006/main" prst="rect">
-            <a:avLst/>
-          </a:prstGeom>
-          <a:noFill xmlns:a="http://schemas.openxmlformats.org/drawingml/2006/main"/>
-          <a:ln xmlns:a="http://schemas.openxmlformats.org/drawingml/2006/main" w="0">
-            <a:noFill/>
-            <a:prstDash val="solid"/>
-          </a:ln>
-        </p:spPr>
-        <p:txBody>
-          <a:bodyPr xmlns:a="http://schemas.openxmlformats.org/drawingml/2006/main" lIns="0" tIns="0" rIns="0" bIns="0" anchor="t">
-            <a:normAutofit fontScale="100000"/>
-          </a:bodyPr>
-          <a:lstStyle xmlns:a="http://schemas.openxmlformats.org/drawingml/2006/main"/>
-          <a:p xmlns:a="http://schemas.openxmlformats.org/drawingml/2006/main">
-            <a:pPr>
-              <a:buNone/>
-              <a:defRPr sz="1725" b="1">
-                <a:solidFill>
-                  <a:srgbClr val="14213D"/>
-                </a:solidFill>
-                <a:latin typeface="Georgia"/>
-                <a:ea typeface="Georgia"/>
-                <a:cs typeface="Georgia"/>
-              </a:defRPr>
-            </a:pPr>
-            <a:r>
-              <a:rPr sz="1725" b="1">
-                <a:solidFill>
-                  <a:srgbClr val="14213D"/>
-                </a:solidFill>
-                <a:latin typeface="Georgia"/>
-                <a:ea typeface="Georgia"/>
-                <a:cs typeface="Georgia"/>
-              </a:rPr>
-              <a:t>What the platform adds</a:t>
-            </a:r>
-          </a:p>
-        </p:txBody>
-      </p:sp>
-      <p:sp>
-        <p:nvSpPr>
-          <p:cNvPr id="10" name="">
-            <a:extLst xmlns:a="http://schemas.openxmlformats.org/drawingml/2006/main">
-              <a:ext uri="{FF2B5EF4-FFF2-40B4-BE49-F238E27FC236}">
-                <a16:creationId xmlns:a16="http://schemas.microsoft.com/office/drawing/2014/main" id="{A4A2429C-939D-4C2C-8727-F53BA3D9C158}"/>
-              </a:ext>
-            </a:extLst>
-          </p:cNvPr>
-          <p:cNvSpPr>
-            <a:spLocks xmlns:a="http://schemas.openxmlformats.org/drawingml/2006/main" noGrp="1"/>
-          </p:cNvSpPr>
-          <p:nvPr/>
-        </p:nvSpPr>
-        <p:spPr>
-          <a:xfrm xmlns:a="http://schemas.openxmlformats.org/drawingml/2006/main">
-            <a:off x="7010400" y="2781300"/>
-            <a:ext cx="4419600" cy="781050"/>
-          </a:xfrm>
-          <a:prstGeom xmlns:a="http://schemas.openxmlformats.org/drawingml/2006/main" prst="rect">
-            <a:avLst/>
-          </a:prstGeom>
-          <a:noFill xmlns:a="http://schemas.openxmlformats.org/drawingml/2006/main"/>
-          <a:ln xmlns:a="http://schemas.openxmlformats.org/drawingml/2006/main" w="0">
-            <a:noFill/>
-            <a:prstDash val="solid"/>
-          </a:ln>
-        </p:spPr>
-        <p:txBody>
-          <a:bodyPr xmlns:a="http://schemas.openxmlformats.org/drawingml/2006/main" lIns="0" tIns="0" rIns="0" bIns="0" anchor="t">
-            <a:normAutofit fontScale="100000"/>
-          </a:bodyPr>
-          <a:lstStyle xmlns:a="http://schemas.openxmlformats.org/drawingml/2006/main"/>
-          <a:p xmlns:a="http://schemas.openxmlformats.org/drawingml/2006/main">
-            <a:pPr>
-              <a:lnSpc>
-                <a:spcPct val="115000"/>
-              </a:lnSpc>
-              <a:buNone/>
-              <a:defRPr sz="1500">
-                <a:solidFill>
-                  <a:srgbClr val="5C6577"/>
-                </a:solidFill>
-                <a:latin typeface="Avenir Next"/>
-                <a:ea typeface="Avenir Next"/>
-                <a:cs typeface="Avenir Next"/>
-              </a:defRPr>
-            </a:pPr>
-            <a:r>
-              <a:rPr sz="1500">
-                <a:solidFill>
-                  <a:srgbClr val="5C6577"/>
-                </a:solidFill>
-                <a:latin typeface="Avenir Next"/>
-                <a:ea typeface="Avenir Next"/>
-                <a:cs typeface="Avenir Next"/>
-              </a:rPr>
-              <a:t>Dashboard · managed infrastructure · API services · authentication · logs · configuration</a:t>
-            </a:r>
-          </a:p>
-        </p:txBody>
-      </p:sp>
-      <p:sp>
-        <p:nvSpPr>
-          <p:cNvPr id="11" name="">
-            <a:extLst xmlns:a="http://schemas.openxmlformats.org/drawingml/2006/main">
-              <a:ext uri="{FF2B5EF4-FFF2-40B4-BE49-F238E27FC236}">
-                <a16:creationId xmlns:a16="http://schemas.microsoft.com/office/drawing/2014/main" id="{EF0B558B-4286-42B8-8EF5-A7CA375CA847}"/>
-              </a:ext>
-            </a:extLst>
-          </p:cNvPr>
-          <p:cNvSpPr>
-            <a:spLocks xmlns:a="http://schemas.openxmlformats.org/drawingml/2006/main" noGrp="1"/>
-          </p:cNvSpPr>
-          <p:nvPr/>
-        </p:nvSpPr>
-        <p:spPr>
-          <a:xfrm xmlns:a="http://schemas.openxmlformats.org/drawingml/2006/main">
-            <a:off x="6762750" y="4048125"/>
-            <a:ext cx="4876800" cy="1619250"/>
-          </a:xfrm>
-          <a:prstGeom xmlns:a="http://schemas.openxmlformats.org/drawingml/2006/main" prst="roundRect">
-            <a:avLst>
-              <a:gd name="adj" fmla="val 10588"/>
-            </a:avLst>
-          </a:prstGeom>
-          <a:solidFill xmlns:a="http://schemas.openxmlformats.org/drawingml/2006/main">
-            <a:srgbClr val="F1FBF8"/>
-          </a:solidFill>
-          <a:ln xmlns:a="http://schemas.openxmlformats.org/drawingml/2006/main" w="9525">
-            <a:solidFill>
-              <a:srgbClr val="E9E4D8"/>
-            </a:solidFill>
-            <a:prstDash val="solid"/>
-          </a:ln>
-        </p:spPr>
-        <p:style>
-          <a:lnRef xmlns:a="http://schemas.openxmlformats.org/drawingml/2006/main" idx="0"/>
-          <a:fillRef xmlns:a="http://schemas.openxmlformats.org/drawingml/2006/main" idx="0"/>
-          <a:effectRef xmlns:a="http://schemas.openxmlformats.org/drawingml/2006/main" idx="4"/>
-          <a:fontRef xmlns:a="http://schemas.openxmlformats.org/drawingml/2006/main" idx="major"/>
-        </p:style>
-      </p:sp>
-      <p:sp>
-        <p:nvSpPr>
-          <p:cNvPr id="12" name="">
-            <a:extLst xmlns:a="http://schemas.openxmlformats.org/drawingml/2006/main">
-              <a:ext uri="{FF2B5EF4-FFF2-40B4-BE49-F238E27FC236}">
-                <a16:creationId xmlns:a16="http://schemas.microsoft.com/office/drawing/2014/main" id="{6A6C8486-5FCB-447A-AE68-6776F77A6DDC}"/>
-              </a:ext>
-            </a:extLst>
-          </p:cNvPr>
-          <p:cNvSpPr>
-            <a:spLocks xmlns:a="http://schemas.openxmlformats.org/drawingml/2006/main" noGrp="1"/>
-          </p:cNvSpPr>
-          <p:nvPr/>
-        </p:nvSpPr>
-        <p:spPr>
-          <a:xfrm xmlns:a="http://schemas.openxmlformats.org/drawingml/2006/main">
-            <a:off x="6762750" y="4048125"/>
-            <a:ext cx="76200" cy="1619250"/>
-          </a:xfrm>
-          <a:prstGeom xmlns:a="http://schemas.openxmlformats.org/drawingml/2006/main" prst="rect">
-            <a:avLst/>
-          </a:prstGeom>
-          <a:solidFill xmlns:a="http://schemas.openxmlformats.org/drawingml/2006/main">
-            <a:srgbClr val="007C77"/>
-          </a:solidFill>
-          <a:ln xmlns:a="http://schemas.openxmlformats.org/drawingml/2006/main" w="0">
-            <a:solidFill>
-              <a:srgbClr val="007C77"/>
-            </a:solidFill>
-            <a:prstDash val="solid"/>
-          </a:ln>
-        </p:spPr>
-      </p:sp>
-      <p:sp>
-        <p:nvSpPr>
-          <p:cNvPr id="13" name="">
-            <a:extLst xmlns:a="http://schemas.openxmlformats.org/drawingml/2006/main">
-              <a:ext uri="{FF2B5EF4-FFF2-40B4-BE49-F238E27FC236}">
-                <a16:creationId xmlns:a16="http://schemas.microsoft.com/office/drawing/2014/main" id="{641C6C60-CA5A-4B2B-9245-B18491BCA480}"/>
-              </a:ext>
-            </a:extLst>
-          </p:cNvPr>
-          <p:cNvSpPr>
-            <a:spLocks xmlns:a="http://schemas.openxmlformats.org/drawingml/2006/main" noGrp="1"/>
-          </p:cNvSpPr>
-          <p:nvPr/>
-        </p:nvSpPr>
-        <p:spPr>
-          <a:xfrm xmlns:a="http://schemas.openxmlformats.org/drawingml/2006/main">
-            <a:off x="7010400" y="4238625"/>
-            <a:ext cx="4419600" cy="361950"/>
-          </a:xfrm>
-          <a:prstGeom xmlns:a="http://schemas.openxmlformats.org/drawingml/2006/main" prst="rect">
-            <a:avLst/>
-          </a:prstGeom>
-          <a:noFill xmlns:a="http://schemas.openxmlformats.org/drawingml/2006/main"/>
-          <a:ln xmlns:a="http://schemas.openxmlformats.org/drawingml/2006/main" w="0">
-            <a:noFill/>
-            <a:prstDash val="solid"/>
-          </a:ln>
-        </p:spPr>
-        <p:txBody>
-          <a:bodyPr xmlns:a="http://schemas.openxmlformats.org/drawingml/2006/main" lIns="0" tIns="0" rIns="0" bIns="0" anchor="t">
-            <a:normAutofit fontScale="100000"/>
-          </a:bodyPr>
-          <a:lstStyle xmlns:a="http://schemas.openxmlformats.org/drawingml/2006/main"/>
-          <a:p xmlns:a="http://schemas.openxmlformats.org/drawingml/2006/main">
-            <a:pPr>
-              <a:buNone/>
-              <a:defRPr sz="1725" b="1">
-                <a:solidFill>
-                  <a:srgbClr val="14213D"/>
-                </a:solidFill>
-                <a:latin typeface="Georgia"/>
-                <a:ea typeface="Georgia"/>
-                <a:cs typeface="Georgia"/>
-              </a:defRPr>
-            </a:pPr>
-            <a:r>
-              <a:rPr sz="1725" b="1">
-                <a:solidFill>
-                  <a:srgbClr val="14213D"/>
-                </a:solidFill>
-                <a:latin typeface="Georgia"/>
-                <a:ea typeface="Georgia"/>
-                <a:cs typeface="Georgia"/>
-              </a:rPr>
-              <a:t>What PostgreSQL still does</a:t>
-            </a:r>
-          </a:p>
-        </p:txBody>
-      </p:sp>
-      <p:sp>
-        <p:nvSpPr>
-          <p:cNvPr id="14" name="">
-            <a:extLst xmlns:a="http://schemas.openxmlformats.org/drawingml/2006/main">
-              <a:ext uri="{FF2B5EF4-FFF2-40B4-BE49-F238E27FC236}">
-                <a16:creationId xmlns:a16="http://schemas.microsoft.com/office/drawing/2014/main" id="{FD370C2A-FD96-4619-8A67-FD46797A4FD2}"/>
-              </a:ext>
-            </a:extLst>
-          </p:cNvPr>
-          <p:cNvSpPr>
-            <a:spLocks xmlns:a="http://schemas.openxmlformats.org/drawingml/2006/main" noGrp="1"/>
-          </p:cNvSpPr>
-          <p:nvPr/>
-        </p:nvSpPr>
-        <p:spPr>
-          <a:xfrm xmlns:a="http://schemas.openxmlformats.org/drawingml/2006/main">
-            <a:off x="7010400" y="4686300"/>
-            <a:ext cx="4419600" cy="781050"/>
-          </a:xfrm>
-          <a:prstGeom xmlns:a="http://schemas.openxmlformats.org/drawingml/2006/main" prst="rect">
-            <a:avLst/>
-          </a:prstGeom>
-          <a:noFill xmlns:a="http://schemas.openxmlformats.org/drawingml/2006/main"/>
-          <a:ln xmlns:a="http://schemas.openxmlformats.org/drawingml/2006/main" w="0">
-            <a:noFill/>
-            <a:prstDash val="solid"/>
-          </a:ln>
-        </p:spPr>
-        <p:txBody>
-          <a:bodyPr xmlns:a="http://schemas.openxmlformats.org/drawingml/2006/main" lIns="0" tIns="0" rIns="0" bIns="0" anchor="t">
-            <a:normAutofit fontScale="100000"/>
-          </a:bodyPr>
-          <a:lstStyle xmlns:a="http://schemas.openxmlformats.org/drawingml/2006/main"/>
-          <a:p xmlns:a="http://schemas.openxmlformats.org/drawingml/2006/main">
-            <a:pPr>
-              <a:lnSpc>
-                <a:spcPct val="115000"/>
-              </a:lnSpc>
-              <a:buNone/>
-              <a:defRPr sz="1500">
-                <a:solidFill>
-                  <a:srgbClr val="5C6577"/>
-                </a:solidFill>
-                <a:latin typeface="Avenir Next"/>
-                <a:ea typeface="Avenir Next"/>
-                <a:cs typeface="Avenir Next"/>
-              </a:defRPr>
-            </a:pPr>
-            <a:r>
-              <a:rPr sz="1500">
-                <a:solidFill>
-                  <a:srgbClr val="5C6577"/>
-                </a:solidFill>
-                <a:latin typeface="Avenir Next"/>
-                <a:ea typeface="Avenir Next"/>
-                <a:cs typeface="Avenir Next"/>
-              </a:rPr>
-              <a:t>Tables · SQL · constraints · transactions · query planning · indexes · roles</a:t>
-            </a:r>
-          </a:p>
-        </p:txBody>
-      </p:sp>
-    </p:spTree>
-    <p:extLst>
-      <p:ext uri="{BB962C8B-B14F-4D97-AF65-F5344CB8AC3E}">
-        <p14:creationId xmlns:p14="http://schemas.microsoft.com/office/powerpoint/2010/main" val="279149357"/>
-      </p:ext>
-    </p:extLst>
-  </p:cSld>
-</p:sld>
+<ns0:sld xmlns:ns0="http://schemas.openxmlformats.org/presentationml/2006/main" xmlns:ns1="http://schemas.openxmlformats.org/drawingml/2006/main" xmlns:ns2="http://schemas.microsoft.com/office/drawing/2014/main" xmlns:ns3="http://schemas.openxmlformats.org/officeDocument/2006/relationships" xmlns:ns4="http://schemas.microsoft.com/office/powerpoint/2010/main">
+  <ns0:cSld>
+    <ns0:bg>
+      <ns0:bgPr>
+        <ns1:solidFill>
+          <ns1:srgbClr val="F7F3EA"/>
+        </ns1:solidFill>
+      </ns0:bgPr>
+    </ns0:bg>
+    <ns0:spTree>
+      <ns0:nvGrpSpPr>
+        <ns0:cNvPr id="1" name=""/>
+        <ns0:cNvGrpSpPr/>
+        <ns0:nvPr/>
+      </ns0:nvGrpSpPr>
+      <ns0:grpSpPr>
+        <ns1:xfrm/>
+      </ns0:grpSpPr>
+      <ns0:sp>
+        <ns0:nvSpPr>
+          <ns0:cNvPr id="15" name="">
+            <ns1:extLst>
+              <ns1:ext uri="{FF2B5EF4-FFF2-40B4-BE49-F238E27FC236}">
+                <ns2:creationId id="{ECE5B4E2-067F-4DCA-8105-FE99E439C22C}"/>
+              </ns1:ext>
+            </ns1:extLst>
+          </ns0:cNvPr>
+          <ns0:cNvSpPr>
+            <ns1:spLocks noGrp="1"/>
+          </ns0:cNvSpPr>
+          <ns0:nvPr/>
+        </ns0:nvSpPr>
+        <ns0:spPr>
+          <ns1:xfrm>
+            <ns1:off x="552450" y="400050"/>
+            <ns1:ext cx="1447800" cy="323850"/>
+          </ns1:xfrm>
+          <ns1:prstGeom prst="roundRect">
+            <ns1:avLst>
+              <ns1:gd name="adj" fmla="val 50000"/>
+            </ns1:avLst>
+          </ns1:prstGeom>
+          <ns1:solidFill>
+            <ns1:srgbClr val="14213D"/>
+          </ns1:solidFill>
+          <ns1:ln w="9525">
+            <ns1:solidFill>
+              <ns1:srgbClr val="14213D"/>
+            </ns1:solidFill>
+            <ns1:prstDash val="solid"/>
+          </ns1:ln>
+        </ns0:spPr>
+        <ns0:txBody>
+          <ns1:bodyPr lIns="76200" tIns="0" rIns="76200" bIns="0" anchor="ctr">
+            <ns1:normAutofit fontScale="96996"/>
+          </ns1:bodyPr>
+          <ns1:lstStyle/>
+          <ns1:p>
+            <ns1:pPr algn="ctr">
+              <ns1:buNone/>
+              <ns1:defRPr sz="1050" b="1">
+                <ns1:solidFill>
+                  <ns1:srgbClr val="FFFFFF"/>
+                </ns1:solidFill>
+                <ns1:latin typeface="Avenir Next"/>
+                <ns1:ea typeface="Avenir Next"/>
+                <ns1:cs typeface="Avenir Next"/>
+              </ns1:defRPr>
+            </ns1:pPr>
+            <ns1:r>
+              <ns1:rPr sz="1050" b="1">
+                <ns1:solidFill>
+                  <ns1:srgbClr val="FFFFFF"/>
+                </ns1:solidFill>
+                <ns1:latin typeface="Avenir Next"/>
+                <ns1:ea typeface="Avenir Next"/>
+                <ns1:cs typeface="Avenir Next"/>
+              </ns1:rPr>
+              <ns1:t>CLOUD INTERFACE</ns1:t>
+            </ns1:r>
+          </ns1:p>
+        </ns0:txBody>
+      </ns0:sp>
+      <ns0:sp>
+        <ns0:nvSpPr>
+          <ns0:cNvPr id="2" name="slide-title">
+            <ns1:extLst>
+              <ns1:ext uri="{FF2B5EF4-FFF2-40B4-BE49-F238E27FC236}">
+                <ns2:creationId id="{4EE0B915-1960-47EC-9286-DC4133E09536}"/>
+              </ns1:ext>
+            </ns1:extLst>
+          </ns0:cNvPr>
+          <ns0:cNvSpPr>
+            <ns1:spLocks noGrp="1"/>
+          </ns0:cNvSpPr>
+          <ns0:nvPr/>
+        </ns0:nvSpPr>
+        <ns0:spPr>
+          <ns1:xfrm>
+            <ns1:off x="552450" y="876300"/>
+            <ns1:ext cx="11087100" cy="704850"/>
+          </ns1:xfrm>
+          <ns1:prstGeom prst="rect">
+            <ns1:avLst/>
+          </ns1:prstGeom>
+          <ns1:noFill/>
+          <ns1:ln w="0">
+            <ns1:noFill/>
+            <ns1:prstDash val="solid"/>
+          </ns1:ln>
+        </ns0:spPr>
+        <ns0:txBody>
+          <ns1:bodyPr lIns="0" tIns="0" rIns="0" bIns="0" anchor="t">
+            <ns1:normAutofit fontScale="100000"/>
+          </ns1:bodyPr>
+          <ns1:lstStyle/>
+          <ns1:p>
+            <ns1:pPr>
+              <ns1:lnSpc>
+                <ns1:spcPct val="95000"/>
+              </ns1:lnSpc>
+              <ns1:buNone/>
+              <ns1:defRPr sz="3000" b="1">
+                <ns1:solidFill>
+                  <ns1:srgbClr val="14213D"/>
+                </ns1:solidFill>
+                <ns1:latin typeface="Georgia"/>
+                <ns1:ea typeface="Georgia"/>
+                <ns1:cs typeface="Georgia"/>
+              </ns1:defRPr>
+            </ns1:pPr>
+            <ns1:r>
+              <ns1:rPr sz="3000" b="1">
+                <ns1:solidFill>
+                  <ns1:srgbClr val="14213D"/>
+                </ns1:solidFill>
+                <ns1:latin typeface="Georgia"/>
+                <ns1:ea typeface="Georgia"/>
+                <ns1:cs typeface="Georgia"/>
+              </ns1:rPr>
+              <ns1:t>Supabase is a platform built around PostgreSQL</ns1:t>
+            </ns1:r>
+          </ns1:p>
+        </ns0:txBody>
+      </ns0:sp>
+      <ns0:sp>
+        <ns0:nvSpPr>
+          <ns0:cNvPr id="3" name="">
+            <ns1:extLst>
+              <ns1:ext uri="{FF2B5EF4-FFF2-40B4-BE49-F238E27FC236}">
+                <ns2:creationId id="{9C69D724-C471-40F9-BE5A-7CF3D5C1EC8C}"/>
+              </ns1:ext>
+            </ns1:extLst>
+          </ns0:cNvPr>
+          <ns0:cNvSpPr>
+            <ns1:spLocks noGrp="1"/>
+          </ns0:cNvSpPr>
+          <ns0:nvPr/>
+        </ns0:nvSpPr>
+        <ns0:spPr>
+          <ns1:xfrm>
+            <ns1:off x="571500" y="1562100"/>
+            <ns1:ext cx="10477500" cy="381000"/>
+          </ns1:xfrm>
+          <ns1:prstGeom prst="rect">
+            <ns1:avLst/>
+          </ns1:prstGeom>
+          <ns1:noFill/>
+          <ns1:ln w="0">
+            <ns1:noFill/>
+            <ns1:prstDash val="solid"/>
+          </ns1:ln>
+        </ns0:spPr>
+        <ns0:txBody>
+          <ns1:bodyPr lIns="0" tIns="0" rIns="0" bIns="0" anchor="t">
+            <ns1:normAutofit fontScale="100000"/>
+          </ns1:bodyPr>
+          <ns1:lstStyle/>
+          <ns1:p>
+            <ns1:pPr>
+              <ns1:buNone/>
+              <ns1:defRPr sz="1425">
+                <ns1:solidFill>
+                  <ns1:srgbClr val="5C6577"/>
+                </ns1:solidFill>
+                <ns1:latin typeface="Avenir Next"/>
+                <ns1:ea typeface="Avenir Next"/>
+                <ns1:cs typeface="Avenir Next"/>
+              </ns1:defRPr>
+            </ns1:pPr>
+            <ns1:r>
+              <ns1:rPr sz="1425">
+                <ns1:solidFill>
+                  <ns1:srgbClr val="5C6577"/>
+                </ns1:solidFill>
+                <ns1:latin typeface="Avenir Next"/>
+                <ns1:ea typeface="Avenir Next"/>
+                <ns1:cs typeface="Avenir Next"/>
+              </ns1:rPr>
+              <ns1:t>The dashboard exposes projects and services; PostgreSQL remains the database engine.</ns1:t>
+            </ns1:r>
+          </ns1:p>
+        </ns0:txBody>
+      </ns0:sp>
+      <ns0:sp>
+        <ns0:nvSpPr>
+          <ns0:cNvPr id="4" name="">
+            <ns1:extLst>
+              <ns1:ext uri="{FF2B5EF4-FFF2-40B4-BE49-F238E27FC236}">
+                <ns2:creationId id="{EC90CB12-698B-49BA-8F98-BAD9E65B7181}"/>
+              </ns1:ext>
+            </ns1:extLst>
+          </ns0:cNvPr>
+          <ns0:cNvSpPr>
+            <ns1:spLocks noGrp="1"/>
+          </ns0:cNvSpPr>
+          <ns0:nvPr/>
+        </ns0:nvSpPr>
+        <ns0:spPr>
+          <ns1:xfrm>
+            <ns1:off x="11144250" y="6334125"/>
+            <ns1:ext cx="495300" cy="228600"/>
+          </ns1:xfrm>
+          <ns1:prstGeom prst="rect">
+            <ns1:avLst/>
+          </ns1:prstGeom>
+          <ns1:noFill/>
+          <ns1:ln w="0">
+            <ns1:noFill/>
+            <ns1:prstDash val="solid"/>
+          </ns1:ln>
+        </ns0:spPr>
+        <ns0:txBody>
+          <ns1:bodyPr wrap="square" lIns="0" tIns="0" rIns="0" bIns="0" anchor="t">
+            <ns1:noAutofit/>
+          </ns1:bodyPr>
+          <ns1:lstStyle/>
+          <ns1:p>
+            <ns1:pPr algn="r">
+              <ns1:buNone/>
+              <ns1:defRPr sz="1050" b="1">
+                <ns1:solidFill>
+                  <ns1:srgbClr val="5C6577"/>
+                </ns1:solidFill>
+                <ns1:latin typeface="Menlo"/>
+                <ns1:ea typeface="Menlo"/>
+                <ns1:cs typeface="Menlo"/>
+              </ns1:defRPr>
+            </ns1:pPr>
+            <ns1:r>
+              <ns1:rPr sz="1050" b="1">
+                <ns1:solidFill>
+                  <ns1:srgbClr val="5C6577"/>
+                </ns1:solidFill>
+                <ns1:latin typeface="Menlo"/>
+                <ns1:ea typeface="Menlo"/>
+                <ns1:cs typeface="Menlo"/>
+              </ns1:rPr>
+              <ns1:t>05</ns1:t>
+            </ns1:r>
+          </ns1:p>
+        </ns0:txBody>
+      </ns0:sp>
+      <ns0:sp>
+        <ns0:nvSpPr>
+          <ns0:cNvPr id="5" name="">
+            <ns1:extLst>
+              <ns1:ext uri="{FF2B5EF4-FFF2-40B4-BE49-F238E27FC236}">
+                <ns2:creationId id="{A420DB7B-3F95-4CE2-B782-695A52096B0F}"/>
+              </ns1:ext>
+            </ns1:extLst>
+          </ns0:cNvPr>
+          <ns0:cNvSpPr>
+            <ns1:spLocks noGrp="1"/>
+          </ns0:cNvSpPr>
+          <ns0:nvPr/>
+        </ns0:nvSpPr>
+        <ns0:spPr>
+          <ns1:xfrm>
+            <ns1:off x="552450" y="2038350"/>
+            <ns1:ext cx="5810250" cy="4095750"/>
+          </ns1:xfrm>
+          <ns1:prstGeom prst="roundRect">
+            <ns1:avLst>
+              <ns1:gd name="adj" fmla="val 4186"/>
+            </ns1:avLst>
+          </ns1:prstGeom>
+          <ns1:solidFill>
+            <ns1:srgbClr val="FFFFFF"/>
+          </ns1:solidFill>
+          <ns1:ln w="9525">
+            <ns1:solidFill>
+              <ns1:srgbClr val="E9E4D8"/>
+            </ns1:solidFill>
+            <ns1:prstDash val="solid"/>
+          </ns1:ln>
+        </ns0:spPr>
+      </ns0:sp>
+      <ns0:pic>
+        <ns0:nvPicPr>
+          <ns0:cNvPr id="22" name="" descr="Supabase project overview, captured August 25, 2026 with account details redacted. The visible dashboard reports Healthy status, Nano compute, no connected GitHub repository, and No backups. A Primary Database panel displays CPU, disk, RAM, and connection usage. These management controls surround the PostgreSQL database engine."/>
+          <ns0:cNvPicPr>
+            <ns1:picLocks noChangeAspect="1"/>
+          </ns0:cNvPicPr>
+          <ns0:nvPr/>
+        </ns0:nvPicPr>
+        <ns0:blipFill>
+          <ns1:blip ns3:embed="Ra9a661b4d442464f"/>
+          <ns1:srcRect l="0" t="21016" r="0" b="21016"/>
+          <ns1:stretch>
+            <ns1:fillRect l="0" t="0" r="0" b="0"/>
+          </ns1:stretch>
+        </ns0:blipFill>
+        <ns0:spPr>
+          <ns1:xfrm>
+            <ns1:off x="714375" y="2181225"/>
+            <ns1:ext cx="5486400" cy="3810000"/>
+          </ns1:xfrm>
+          <ns1:prstGeom prst="roundRect">
+            <ns1:avLst>
+              <ns1:gd name="adj" fmla="val 3000"/>
+            </ns1:avLst>
+          </ns1:prstGeom>
+        </ns0:spPr>
+      </ns0:pic>
+      <ns0:sp>
+        <ns0:nvSpPr>
+          <ns0:cNvPr id="7" name="">
+            <ns1:extLst>
+              <ns1:ext uri="{FF2B5EF4-FFF2-40B4-BE49-F238E27FC236}">
+                <ns2:creationId id="{2E7E305D-5ADE-42FC-9B30-AD0427C6DC83}"/>
+              </ns1:ext>
+            </ns1:extLst>
+          </ns0:cNvPr>
+          <ns0:cNvSpPr>
+            <ns1:spLocks noGrp="1"/>
+          </ns0:cNvSpPr>
+          <ns0:nvPr/>
+        </ns0:nvSpPr>
+        <ns0:spPr>
+          <ns1:xfrm>
+            <ns1:off x="6762750" y="2143125"/>
+            <ns1:ext cx="4876800" cy="1619250"/>
+          </ns1:xfrm>
+          <ns1:prstGeom prst="roundRect">
+            <ns1:avLst>
+              <ns1:gd name="adj" fmla="val 10588"/>
+            </ns1:avLst>
+          </ns1:prstGeom>
+          <ns1:solidFill>
+            <ns1:srgbClr val="F4F8FF"/>
+          </ns1:solidFill>
+          <ns1:ln w="9525">
+            <ns1:solidFill>
+              <ns1:srgbClr val="E9E4D8"/>
+            </ns1:solidFill>
+            <ns1:prstDash val="solid"/>
+          </ns1:ln>
+        </ns0:spPr>
+        <ns0:style>
+          <ns1:lnRef idx="0"/>
+          <ns1:fillRef idx="0"/>
+          <ns1:effectRef idx="4"/>
+          <ns1:fontRef idx="major"/>
+        </ns0:style>
+      </ns0:sp>
+      <ns0:sp>
+        <ns0:nvSpPr>
+          <ns0:cNvPr id="8" name="">
+            <ns1:extLst>
+              <ns1:ext uri="{FF2B5EF4-FFF2-40B4-BE49-F238E27FC236}">
+                <ns2:creationId id="{A2DC7162-A4DE-4D19-AF39-7A86DC8D6B78}"/>
+              </ns1:ext>
+            </ns1:extLst>
+          </ns0:cNvPr>
+          <ns0:cNvSpPr>
+            <ns1:spLocks noGrp="1"/>
+          </ns0:cNvSpPr>
+          <ns0:nvPr/>
+        </ns0:nvSpPr>
+        <ns0:spPr>
+          <ns1:xfrm>
+            <ns1:off x="6762750" y="2143125"/>
+            <ns1:ext cx="76200" cy="1619250"/>
+          </ns1:xfrm>
+          <ns1:prstGeom prst="rect">
+            <ns1:avLst/>
+          </ns1:prstGeom>
+          <ns1:solidFill>
+            <ns1:srgbClr val="0B5FFF"/>
+          </ns1:solidFill>
+          <ns1:ln w="0">
+            <ns1:solidFill>
+              <ns1:srgbClr val="0B5FFF"/>
+            </ns1:solidFill>
+            <ns1:prstDash val="solid"/>
+          </ns1:ln>
+        </ns0:spPr>
+      </ns0:sp>
+      <ns0:sp>
+        <ns0:nvSpPr>
+          <ns0:cNvPr id="9" name="">
+            <ns1:extLst>
+              <ns1:ext uri="{FF2B5EF4-FFF2-40B4-BE49-F238E27FC236}">
+                <ns2:creationId id="{44E97D5F-4372-4193-A08D-E443E636BCC3}"/>
+              </ns1:ext>
+            </ns1:extLst>
+          </ns0:cNvPr>
+          <ns0:cNvSpPr>
+            <ns1:spLocks noGrp="1"/>
+          </ns0:cNvSpPr>
+          <ns0:nvPr/>
+        </ns0:nvSpPr>
+        <ns0:spPr>
+          <ns1:xfrm>
+            <ns1:off x="7010400" y="2333625"/>
+            <ns1:ext cx="4419600" cy="361950"/>
+          </ns1:xfrm>
+          <ns1:prstGeom prst="rect">
+            <ns1:avLst/>
+          </ns1:prstGeom>
+          <ns1:noFill/>
+          <ns1:ln w="0">
+            <ns1:noFill/>
+            <ns1:prstDash val="solid"/>
+          </ns1:ln>
+        </ns0:spPr>
+        <ns0:txBody>
+          <ns1:bodyPr lIns="0" tIns="0" rIns="0" bIns="0" anchor="t">
+            <ns1:normAutofit fontScale="100000"/>
+          </ns1:bodyPr>
+          <ns1:lstStyle/>
+          <ns1:p>
+            <ns1:pPr>
+              <ns1:buNone/>
+              <ns1:defRPr sz="1725" b="1">
+                <ns1:solidFill>
+                  <ns1:srgbClr val="14213D"/>
+                </ns1:solidFill>
+                <ns1:latin typeface="Georgia"/>
+                <ns1:ea typeface="Georgia"/>
+                <ns1:cs typeface="Georgia"/>
+              </ns1:defRPr>
+            </ns1:pPr>
+            <ns1:r>
+              <ns1:rPr sz="1725" b="1">
+                <ns1:solidFill>
+                  <ns1:srgbClr val="14213D"/>
+                </ns1:solidFill>
+                <ns1:latin typeface="Georgia"/>
+                <ns1:ea typeface="Georgia"/>
+                <ns1:cs typeface="Georgia"/>
+              </ns1:rPr>
+              <ns1:t>What the platform adds</ns1:t>
+            </ns1:r>
+          </ns1:p>
+        </ns0:txBody>
+      </ns0:sp>
+      <ns0:sp>
+        <ns0:nvSpPr>
+          <ns0:cNvPr id="10" name="">
+            <ns1:extLst>
+              <ns1:ext uri="{FF2B5EF4-FFF2-40B4-BE49-F238E27FC236}">
+                <ns2:creationId id="{A4A2429C-939D-4C2C-8727-F53BA3D9C158}"/>
+              </ns1:ext>
+            </ns1:extLst>
+          </ns0:cNvPr>
+          <ns0:cNvSpPr>
+            <ns1:spLocks noGrp="1"/>
+          </ns0:cNvSpPr>
+          <ns0:nvPr/>
+        </ns0:nvSpPr>
+        <ns0:spPr>
+          <ns1:xfrm>
+            <ns1:off x="7010400" y="2781300"/>
+            <ns1:ext cx="4419600" cy="781050"/>
+          </ns1:xfrm>
+          <ns1:prstGeom prst="rect">
+            <ns1:avLst/>
+          </ns1:prstGeom>
+          <ns1:noFill/>
+          <ns1:ln w="0">
+            <ns1:noFill/>
+            <ns1:prstDash val="solid"/>
+          </ns1:ln>
+        </ns0:spPr>
+        <ns0:txBody>
+          <ns1:bodyPr lIns="0" tIns="0" rIns="0" bIns="0" anchor="t">
+            <ns1:normAutofit fontScale="100000"/>
+          </ns1:bodyPr>
+          <ns1:lstStyle/>
+          <ns1:p>
+            <ns1:pPr>
+              <ns1:lnSpc>
+                <ns1:spcPct val="115000"/>
+              </ns1:lnSpc>
+              <ns1:buNone/>
+              <ns1:defRPr sz="1500">
+                <ns1:solidFill>
+                  <ns1:srgbClr val="5C6577"/>
+                </ns1:solidFill>
+                <ns1:latin typeface="Avenir Next"/>
+                <ns1:ea typeface="Avenir Next"/>
+                <ns1:cs typeface="Avenir Next"/>
+              </ns1:defRPr>
+            </ns1:pPr>
+            <ns1:r>
+              <ns1:rPr sz="1500">
+                <ns1:solidFill>
+                  <ns1:srgbClr val="5C6577"/>
+                </ns1:solidFill>
+                <ns1:latin typeface="Avenir Next"/>
+                <ns1:ea typeface="Avenir Next"/>
+                <ns1:cs typeface="Avenir Next"/>
+              </ns1:rPr>
+              <ns1:t>Dashboard · managed infrastructure · API services · authentication · logs · configuration</ns1:t>
+            </ns1:r>
+          </ns1:p>
+        </ns0:txBody>
+      </ns0:sp>
+      <ns0:sp>
+        <ns0:nvSpPr>
+          <ns0:cNvPr id="11" name="">
+            <ns1:extLst>
+              <ns1:ext uri="{FF2B5EF4-FFF2-40B4-BE49-F238E27FC236}">
+                <ns2:creationId id="{EF0B558B-4286-42B8-8EF5-A7CA375CA847}"/>
+              </ns1:ext>
+            </ns1:extLst>
+          </ns0:cNvPr>
+          <ns0:cNvSpPr>
+            <ns1:spLocks noGrp="1"/>
+          </ns0:cNvSpPr>
+          <ns0:nvPr/>
+        </ns0:nvSpPr>
+        <ns0:spPr>
+          <ns1:xfrm>
+            <ns1:off x="6762750" y="4048125"/>
+            <ns1:ext cx="4876800" cy="1619250"/>
+          </ns1:xfrm>
+          <ns1:prstGeom prst="roundRect">
+            <ns1:avLst>
+              <ns1:gd name="adj" fmla="val 10588"/>
+            </ns1:avLst>
+          </ns1:prstGeom>
+          <ns1:solidFill>
+            <ns1:srgbClr val="F1FBF8"/>
+          </ns1:solidFill>
+          <ns1:ln w="9525">
+            <ns1:solidFill>
+              <ns1:srgbClr val="E9E4D8"/>
+            </ns1:solidFill>
+            <ns1:prstDash val="solid"/>
+          </ns1:ln>
+        </ns0:spPr>
+        <ns0:style>
+          <ns1:lnRef idx="0"/>
+          <ns1:fillRef idx="0"/>
+          <ns1:effectRef idx="4"/>
+          <ns1:fontRef idx="major"/>
+        </ns0:style>
+      </ns0:sp>
+      <ns0:sp>
+        <ns0:nvSpPr>
+          <ns0:cNvPr id="12" name="">
+            <ns1:extLst>
+              <ns1:ext uri="{FF2B5EF4-FFF2-40B4-BE49-F238E27FC236}">
+                <ns2:creationId id="{6A6C8486-5FCB-447A-AE68-6776F77A6DDC}"/>
+              </ns1:ext>
+            </ns1:extLst>
+          </ns0:cNvPr>
+          <ns0:cNvSpPr>
+            <ns1:spLocks noGrp="1"/>
+          </ns0:cNvSpPr>
+          <ns0:nvPr/>
+        </ns0:nvSpPr>
+        <ns0:spPr>
+          <ns1:xfrm>
+            <ns1:off x="6762750" y="4048125"/>
+            <ns1:ext cx="76200" cy="1619250"/>
+          </ns1:xfrm>
+          <ns1:prstGeom prst="rect">
+            <ns1:avLst/>
+          </ns1:prstGeom>
+          <ns1:solidFill>
+            <ns1:srgbClr val="007C77"/>
+          </ns1:solidFill>
+          <ns1:ln w="0">
+            <ns1:solidFill>
+              <ns1:srgbClr val="007C77"/>
+            </ns1:solidFill>
+            <ns1:prstDash val="solid"/>
+          </ns1:ln>
+        </ns0:spPr>
+      </ns0:sp>
+      <ns0:sp>
+        <ns0:nvSpPr>
+          <ns0:cNvPr id="13" name="">
+            <ns1:extLst>
+              <ns1:ext uri="{FF2B5EF4-FFF2-40B4-BE49-F238E27FC236}">
+                <ns2:creationId id="{641C6C60-CA5A-4B2B-9245-B18491BCA480}"/>
+              </ns1:ext>
+            </ns1:extLst>
+          </ns0:cNvPr>
+          <ns0:cNvSpPr>
+            <ns1:spLocks noGrp="1"/>
+          </ns0:cNvSpPr>
+          <ns0:nvPr/>
+        </ns0:nvSpPr>
+        <ns0:spPr>
+          <ns1:xfrm>
+            <ns1:off x="7010400" y="4238625"/>
+            <ns1:ext cx="4419600" cy="361950"/>
+          </ns1:xfrm>
+          <ns1:prstGeom prst="rect">
+            <ns1:avLst/>
+          </ns1:prstGeom>
+          <ns1:noFill/>
+          <ns1:ln w="0">
+            <ns1:noFill/>
+            <ns1:prstDash val="solid"/>
+          </ns1:ln>
+        </ns0:spPr>
+        <ns0:txBody>
+          <ns1:bodyPr lIns="0" tIns="0" rIns="0" bIns="0" anchor="t">
+            <ns1:normAutofit fontScale="100000"/>
+          </ns1:bodyPr>
+          <ns1:lstStyle/>
+          <ns1:p>
+            <ns1:pPr>
+              <ns1:buNone/>
+              <ns1:defRPr sz="1725" b="1">
+                <ns1:solidFill>
+                  <ns1:srgbClr val="14213D"/>
+                </ns1:solidFill>
+                <ns1:latin typeface="Georgia"/>
+                <ns1:ea typeface="Georgia"/>
+                <ns1:cs typeface="Georgia"/>
+              </ns1:defRPr>
+            </ns1:pPr>
+            <ns1:r>
+              <ns1:rPr sz="1725" b="1">
+                <ns1:solidFill>
+                  <ns1:srgbClr val="14213D"/>
+                </ns1:solidFill>
+                <ns1:latin typeface="Georgia"/>
+                <ns1:ea typeface="Georgia"/>
+                <ns1:cs typeface="Georgia"/>
+              </ns1:rPr>
+              <ns1:t>What PostgreSQL still does</ns1:t>
+            </ns1:r>
+          </ns1:p>
+        </ns0:txBody>
+      </ns0:sp>
+      <ns0:sp>
+        <ns0:nvSpPr>
+          <ns0:cNvPr id="14" name="">
+            <ns1:extLst>
+              <ns1:ext uri="{FF2B5EF4-FFF2-40B4-BE49-F238E27FC236}">
+                <ns2:creationId id="{FD370C2A-FD96-4619-8A67-FD46797A4FD2}"/>
+              </ns1:ext>
+            </ns1:extLst>
+          </ns0:cNvPr>
+          <ns0:cNvSpPr>
+            <ns1:spLocks noGrp="1"/>
+          </ns0:cNvSpPr>
+          <ns0:nvPr/>
+        </ns0:nvSpPr>
+        <ns0:spPr>
+          <ns1:xfrm>
+            <ns1:off x="7010400" y="4686300"/>
+            <ns1:ext cx="4419600" cy="781050"/>
+          </ns1:xfrm>
+          <ns1:prstGeom prst="rect">
+            <ns1:avLst/>
+          </ns1:prstGeom>
+          <ns1:noFill/>
+          <ns1:ln w="0">
+            <ns1:noFill/>
+            <ns1:prstDash val="solid"/>
+          </ns1:ln>
+        </ns0:spPr>
+        <ns0:txBody>
+          <ns1:bodyPr lIns="0" tIns="0" rIns="0" bIns="0" anchor="t">
+            <ns1:normAutofit fontScale="100000"/>
+          </ns1:bodyPr>
+          <ns1:lstStyle/>
+          <ns1:p>
+            <ns1:pPr>
+              <ns1:lnSpc>
+                <ns1:spcPct val="115000"/>
+              </ns1:lnSpc>
+              <ns1:buNone/>
+              <ns1:defRPr sz="1500">
+                <ns1:solidFill>
+                  <ns1:srgbClr val="5C6577"/>
+                </ns1:solidFill>
+                <ns1:latin typeface="Avenir Next"/>
+                <ns1:ea typeface="Avenir Next"/>
+                <ns1:cs typeface="Avenir Next"/>
+              </ns1:defRPr>
+            </ns1:pPr>
+            <ns1:r>
+              <ns1:rPr sz="1500">
+                <ns1:solidFill>
+                  <ns1:srgbClr val="5C6577"/>
+                </ns1:solidFill>
+                <ns1:latin typeface="Avenir Next"/>
+                <ns1:ea typeface="Avenir Next"/>
+                <ns1:cs typeface="Avenir Next"/>
+              </ns1:rPr>
+              <ns1:t>Tables · SQL · constraints · transactions · query planning · indexes · roles</ns1:t>
+            </ns1:r>
+          </ns1:p>
+        </ns0:txBody>
+      </ns0:sp>
+    </ns0:spTree>
+    <ns0:extLst>
+      <ns0:ext uri="{BB962C8B-B14F-4D97-AF65-F5344CB8AC3E}">
+        <ns4:creationId val="279149357"/>
+      </ns0:ext>
+    </ns0:extLst>
+  </ns0:cSld>
+</ns0:sld>
 </file>
 
 <file path=ppt/slides/slide6.xml><?xml version="1.0" encoding="utf-8"?>
-<p:sld xmlns:p="http://schemas.openxmlformats.org/presentationml/2006/main">
-  <p:cSld>
-    <p:bg>
-      <p:bgPr>
-        <a:solidFill xmlns:a="http://schemas.openxmlformats.org/drawingml/2006/main">
-          <a:srgbClr val="F7F3EA"/>
-        </a:solidFill>
-      </p:bgPr>
-    </p:bg>
-    <p:spTree>
-      <p:nvGrpSpPr>
-        <p:cNvPr id="1" name=""/>
-        <p:cNvGrpSpPr/>
-        <p:nvPr/>
-      </p:nvGrpSpPr>
-      <p:grpSpPr>
-        <a:xfrm xmlns:a="http://schemas.openxmlformats.org/drawingml/2006/main"/>
-      </p:grpSpPr>
-      <p:sp>
-        <p:nvSpPr>
-          <p:cNvPr id="16" name="">
-            <a:extLst xmlns:a="http://schemas.openxmlformats.org/drawingml/2006/main">
-              <a:ext uri="{FF2B5EF4-FFF2-40B4-BE49-F238E27FC236}">
-                <a16:creationId xmlns:a16="http://schemas.microsoft.com/office/drawing/2014/main" id="{31896894-5F88-4FA0-B8F7-A3B9556AC8AA}"/>
-              </a:ext>
-            </a:extLst>
-          </p:cNvPr>
-          <p:cNvSpPr>
-            <a:spLocks xmlns:a="http://schemas.openxmlformats.org/drawingml/2006/main" noGrp="1"/>
-          </p:cNvSpPr>
-          <p:nvPr/>
-        </p:nvSpPr>
-        <p:spPr>
-          <a:xfrm xmlns:a="http://schemas.openxmlformats.org/drawingml/2006/main">
-            <a:off x="552450" y="400050"/>
-            <a:ext cx="1447800" cy="323850"/>
-          </a:xfrm>
-          <a:prstGeom xmlns:a="http://schemas.openxmlformats.org/drawingml/2006/main" prst="roundRect">
-            <a:avLst>
-              <a:gd name="adj" fmla="val 50000"/>
-            </a:avLst>
-          </a:prstGeom>
-          <a:solidFill xmlns:a="http://schemas.openxmlformats.org/drawingml/2006/main">
-            <a:srgbClr val="14213D"/>
-          </a:solidFill>
-          <a:ln xmlns:a="http://schemas.openxmlformats.org/drawingml/2006/main" w="9525">
-            <a:solidFill>
-              <a:srgbClr val="14213D"/>
-            </a:solidFill>
-            <a:prstDash val="solid"/>
-          </a:ln>
-        </p:spPr>
-        <p:txBody>
-          <a:bodyPr xmlns:a="http://schemas.openxmlformats.org/drawingml/2006/main" lIns="76200" tIns="0" rIns="76200" bIns="0" anchor="ctr">
-            <a:normAutofit fontScale="96996"/>
-          </a:bodyPr>
-          <a:lstStyle xmlns:a="http://schemas.openxmlformats.org/drawingml/2006/main"/>
-          <a:p xmlns:a="http://schemas.openxmlformats.org/drawingml/2006/main">
-            <a:pPr algn="ctr">
-              <a:buNone/>
-              <a:defRPr sz="1050" b="1">
-                <a:solidFill>
-                  <a:srgbClr val="FFFFFF"/>
-                </a:solidFill>
-                <a:latin typeface="Avenir Next"/>
-                <a:ea typeface="Avenir Next"/>
-                <a:cs typeface="Avenir Next"/>
-              </a:defRPr>
-            </a:pPr>
-            <a:r>
-              <a:rPr sz="1050" b="1">
-                <a:solidFill>
-                  <a:srgbClr val="FFFFFF"/>
-                </a:solidFill>
-                <a:latin typeface="Avenir Next"/>
-                <a:ea typeface="Avenir Next"/>
-                <a:cs typeface="Avenir Next"/>
-              </a:rPr>
-              <a:t>CLOUD INTERFACE</a:t>
-            </a:r>
-          </a:p>
-        </p:txBody>
-      </p:sp>
-      <p:sp>
-        <p:nvSpPr>
-          <p:cNvPr id="2" name="slide-title">
-            <a:extLst xmlns:a="http://schemas.openxmlformats.org/drawingml/2006/main">
-              <a:ext uri="{FF2B5EF4-FFF2-40B4-BE49-F238E27FC236}">
-                <a16:creationId xmlns:a16="http://schemas.microsoft.com/office/drawing/2014/main" id="{88388ED0-F419-4FDC-A263-1289F17C48A1}"/>
-              </a:ext>
-            </a:extLst>
-          </p:cNvPr>
-          <p:cNvSpPr>
-            <a:spLocks xmlns:a="http://schemas.openxmlformats.org/drawingml/2006/main" noGrp="1"/>
-          </p:cNvSpPr>
-          <p:nvPr/>
-        </p:nvSpPr>
-        <p:spPr>
-          <a:xfrm xmlns:a="http://schemas.openxmlformats.org/drawingml/2006/main">
-            <a:off x="552450" y="876300"/>
-            <a:ext cx="11087100" cy="704850"/>
-          </a:xfrm>
-          <a:prstGeom xmlns:a="http://schemas.openxmlformats.org/drawingml/2006/main" prst="rect">
-            <a:avLst/>
-          </a:prstGeom>
-          <a:noFill xmlns:a="http://schemas.openxmlformats.org/drawingml/2006/main"/>
-          <a:ln xmlns:a="http://schemas.openxmlformats.org/drawingml/2006/main" w="0">
-            <a:noFill/>
-            <a:prstDash val="solid"/>
-          </a:ln>
-        </p:spPr>
-        <p:txBody>
-          <a:bodyPr xmlns:a="http://schemas.openxmlformats.org/drawingml/2006/main" lIns="0" tIns="0" rIns="0" bIns="0" anchor="t">
-            <a:normAutofit fontScale="100000"/>
-          </a:bodyPr>
-          <a:lstStyle xmlns:a="http://schemas.openxmlformats.org/drawingml/2006/main"/>
-          <a:p xmlns:a="http://schemas.openxmlformats.org/drawingml/2006/main">
-            <a:pPr>
-              <a:lnSpc>
-                <a:spcPct val="95000"/>
-              </a:lnSpc>
-              <a:buNone/>
-              <a:defRPr sz="3000" b="1">
-                <a:solidFill>
-                  <a:srgbClr val="14213D"/>
-                </a:solidFill>
-                <a:latin typeface="Georgia"/>
-                <a:ea typeface="Georgia"/>
-                <a:cs typeface="Georgia"/>
-              </a:defRPr>
-            </a:pPr>
-            <a:r>
-              <a:rPr sz="3000" b="1">
-                <a:solidFill>
-                  <a:srgbClr val="14213D"/>
-                </a:solidFill>
-                <a:latin typeface="Georgia"/>
-                <a:ea typeface="Georgia"/>
-                <a:cs typeface="Georgia"/>
-              </a:rPr>
-              <a:t>MongoDB Atlas operates MongoDB in the cloud</a:t>
-            </a:r>
-          </a:p>
-        </p:txBody>
-      </p:sp>
-      <p:sp>
-        <p:nvSpPr>
-          <p:cNvPr id="3" name="">
-            <a:extLst xmlns:a="http://schemas.openxmlformats.org/drawingml/2006/main">
-              <a:ext uri="{FF2B5EF4-FFF2-40B4-BE49-F238E27FC236}">
-                <a16:creationId xmlns:a16="http://schemas.microsoft.com/office/drawing/2014/main" id="{D26C06D8-0780-4513-AB3F-492DC56C46AA}"/>
-              </a:ext>
-            </a:extLst>
-          </p:cNvPr>
-          <p:cNvSpPr>
-            <a:spLocks xmlns:a="http://schemas.openxmlformats.org/drawingml/2006/main" noGrp="1"/>
-          </p:cNvSpPr>
-          <p:nvPr/>
-        </p:nvSpPr>
-        <p:spPr>
-          <a:xfrm xmlns:a="http://schemas.openxmlformats.org/drawingml/2006/main">
-            <a:off x="571500" y="1562100"/>
-            <a:ext cx="10477500" cy="381000"/>
-          </a:xfrm>
-          <a:prstGeom xmlns:a="http://schemas.openxmlformats.org/drawingml/2006/main" prst="rect">
-            <a:avLst/>
-          </a:prstGeom>
-          <a:noFill xmlns:a="http://schemas.openxmlformats.org/drawingml/2006/main"/>
-          <a:ln xmlns:a="http://schemas.openxmlformats.org/drawingml/2006/main" w="0">
-            <a:noFill/>
-            <a:prstDash val="solid"/>
-          </a:ln>
-        </p:spPr>
-        <p:txBody>
-          <a:bodyPr xmlns:a="http://schemas.openxmlformats.org/drawingml/2006/main" lIns="0" tIns="0" rIns="0" bIns="0" anchor="t">
-            <a:normAutofit fontScale="100000"/>
-          </a:bodyPr>
-          <a:lstStyle xmlns:a="http://schemas.openxmlformats.org/drawingml/2006/main"/>
-          <a:p xmlns:a="http://schemas.openxmlformats.org/drawingml/2006/main">
-            <a:pPr>
-              <a:buNone/>
-              <a:defRPr sz="1425">
-                <a:solidFill>
-                  <a:srgbClr val="5C6577"/>
-                </a:solidFill>
-                <a:latin typeface="Avenir Next"/>
-                <a:ea typeface="Avenir Next"/>
-                <a:cs typeface="Avenir Next"/>
-              </a:defRPr>
-            </a:pPr>
-            <a:r>
-              <a:rPr sz="1425">
-                <a:solidFill>
-                  <a:srgbClr val="5C6577"/>
-                </a:solidFill>
-                <a:latin typeface="Avenir Next"/>
-                <a:ea typeface="Avenir Next"/>
-                <a:cs typeface="Avenir Next"/>
-              </a:rPr>
-              <a:t>Projects, clusters, users, network rules, and data tools surround the document database.</a:t>
-            </a:r>
-          </a:p>
-        </p:txBody>
-      </p:sp>
-      <p:sp>
-        <p:nvSpPr>
-          <p:cNvPr id="4" name="">
-            <a:extLst xmlns:a="http://schemas.openxmlformats.org/drawingml/2006/main">
-              <a:ext uri="{FF2B5EF4-FFF2-40B4-BE49-F238E27FC236}">
-                <a16:creationId xmlns:a16="http://schemas.microsoft.com/office/drawing/2014/main" id="{4D4F6477-AD3C-41DA-A4AD-841179DE5AE4}"/>
-              </a:ext>
-            </a:extLst>
-          </p:cNvPr>
-          <p:cNvSpPr>
-            <a:spLocks xmlns:a="http://schemas.openxmlformats.org/drawingml/2006/main" noGrp="1"/>
-          </p:cNvSpPr>
-          <p:nvPr/>
-        </p:nvSpPr>
-        <p:spPr>
-          <a:xfrm xmlns:a="http://schemas.openxmlformats.org/drawingml/2006/main">
-            <a:off x="11144250" y="6334125"/>
-            <a:ext cx="495300" cy="228600"/>
-          </a:xfrm>
-          <a:prstGeom xmlns:a="http://schemas.openxmlformats.org/drawingml/2006/main" prst="rect">
-            <a:avLst/>
-          </a:prstGeom>
-          <a:noFill xmlns:a="http://schemas.openxmlformats.org/drawingml/2006/main"/>
-          <a:ln xmlns:a="http://schemas.openxmlformats.org/drawingml/2006/main" w="0">
-            <a:noFill/>
-            <a:prstDash val="solid"/>
-          </a:ln>
-        </p:spPr>
-        <p:txBody>
-          <a:bodyPr xmlns:a="http://schemas.openxmlformats.org/drawingml/2006/main" wrap="square" lIns="0" tIns="0" rIns="0" bIns="0" anchor="t">
-            <a:noAutofit/>
-          </a:bodyPr>
-          <a:lstStyle xmlns:a="http://schemas.openxmlformats.org/drawingml/2006/main"/>
-          <a:p xmlns:a="http://schemas.openxmlformats.org/drawingml/2006/main">
-            <a:pPr algn="r">
-              <a:buNone/>
-              <a:defRPr sz="1050" b="1">
-                <a:solidFill>
-                  <a:srgbClr val="5C6577"/>
-                </a:solidFill>
-                <a:latin typeface="Menlo"/>
-                <a:ea typeface="Menlo"/>
-                <a:cs typeface="Menlo"/>
-              </a:defRPr>
-            </a:pPr>
-            <a:r>
-              <a:rPr sz="1050" b="1">
-                <a:solidFill>
-                  <a:srgbClr val="5C6577"/>
-                </a:solidFill>
-                <a:latin typeface="Menlo"/>
-                <a:ea typeface="Menlo"/>
-                <a:cs typeface="Menlo"/>
-              </a:rPr>
-              <a:t>06</a:t>
-            </a:r>
-          </a:p>
-        </p:txBody>
-      </p:sp>
-      <p:sp>
-        <p:nvSpPr>
-          <p:cNvPr id="5" name="">
-            <a:extLst xmlns:a="http://schemas.openxmlformats.org/drawingml/2006/main">
-              <a:ext uri="{FF2B5EF4-FFF2-40B4-BE49-F238E27FC236}">
-                <a16:creationId xmlns:a16="http://schemas.microsoft.com/office/drawing/2014/main" id="{FCB0DB75-0A32-4F59-AF0F-4B76736744AB}"/>
-              </a:ext>
-            </a:extLst>
-          </p:cNvPr>
-          <p:cNvSpPr>
-            <a:spLocks xmlns:a="http://schemas.openxmlformats.org/drawingml/2006/main" noGrp="1"/>
-          </p:cNvSpPr>
-          <p:nvPr/>
-        </p:nvSpPr>
-        <p:spPr>
-          <a:xfrm xmlns:a="http://schemas.openxmlformats.org/drawingml/2006/main">
-            <a:off x="552450" y="2038350"/>
-            <a:ext cx="6858000" cy="4095750"/>
-          </a:xfrm>
-          <a:prstGeom xmlns:a="http://schemas.openxmlformats.org/drawingml/2006/main" prst="roundRect">
-            <a:avLst>
-              <a:gd name="adj" fmla="val 4186"/>
-            </a:avLst>
-          </a:prstGeom>
-          <a:solidFill xmlns:a="http://schemas.openxmlformats.org/drawingml/2006/main">
-            <a:srgbClr val="FFFFFF"/>
-          </a:solidFill>
-          <a:ln xmlns:a="http://schemas.openxmlformats.org/drawingml/2006/main" w="9525">
-            <a:solidFill>
-              <a:srgbClr val="E9E4D8"/>
-            </a:solidFill>
-            <a:prstDash val="solid"/>
-          </a:ln>
-        </p:spPr>
-      </p:sp>
-      <p:pic>
-        <p:nvPicPr>
-          <p:cNvPr id="23" name=""/>
-          <p:cNvPicPr>
-            <a:picLocks xmlns:a="http://schemas.openxmlformats.org/drawingml/2006/main" noChangeAspect="1"/>
-          </p:cNvPicPr>
-          <p:nvPr/>
-        </p:nvPicPr>
-        <p:blipFill>
-          <a:blip xmlns:r="http://schemas.openxmlformats.org/officeDocument/2006/relationships" xmlns:a="http://schemas.openxmlformats.org/drawingml/2006/main" r:embed="R0487ba9696264a22"/>
-          <a:srcRect xmlns:a="http://schemas.openxmlformats.org/drawingml/2006/main" l="0" t="10087" r="0" b="10087"/>
-          <a:stretch xmlns:a="http://schemas.openxmlformats.org/drawingml/2006/main">
-            <a:fillRect l="0" t="0" r="0" b="0"/>
-          </a:stretch>
-        </p:blipFill>
-        <p:spPr>
-          <a:xfrm xmlns:a="http://schemas.openxmlformats.org/drawingml/2006/main">
-            <a:off x="695325" y="2171700"/>
-            <a:ext cx="6572250" cy="3810000"/>
-          </a:xfrm>
-          <a:prstGeom xmlns:a="http://schemas.openxmlformats.org/drawingml/2006/main" prst="roundRect">
-            <a:avLst>
-              <a:gd name="adj" fmla="val 3000"/>
-            </a:avLst>
-          </a:prstGeom>
-        </p:spPr>
-      </p:pic>
-      <p:sp>
-        <p:nvSpPr>
-          <p:cNvPr id="7" name="">
-            <a:extLst xmlns:a="http://schemas.openxmlformats.org/drawingml/2006/main">
-              <a:ext uri="{FF2B5EF4-FFF2-40B4-BE49-F238E27FC236}">
-                <a16:creationId xmlns:a16="http://schemas.microsoft.com/office/drawing/2014/main" id="{A91DD7FA-F4F5-4AC9-A03E-97B14698C09B}"/>
-              </a:ext>
-            </a:extLst>
-          </p:cNvPr>
-          <p:cNvSpPr>
-            <a:spLocks xmlns:a="http://schemas.openxmlformats.org/drawingml/2006/main" noGrp="1"/>
-          </p:cNvSpPr>
-          <p:nvPr/>
-        </p:nvSpPr>
-        <p:spPr>
-          <a:xfrm xmlns:a="http://schemas.openxmlformats.org/drawingml/2006/main">
-            <a:off x="7810500" y="2181225"/>
-            <a:ext cx="3829050" cy="1485900"/>
-          </a:xfrm>
-          <a:prstGeom xmlns:a="http://schemas.openxmlformats.org/drawingml/2006/main" prst="roundRect">
-            <a:avLst>
-              <a:gd name="adj" fmla="val 11538"/>
-            </a:avLst>
-          </a:prstGeom>
-          <a:solidFill xmlns:a="http://schemas.openxmlformats.org/drawingml/2006/main">
-            <a:srgbClr val="F1FBF8"/>
-          </a:solidFill>
-          <a:ln xmlns:a="http://schemas.openxmlformats.org/drawingml/2006/main" w="9525">
-            <a:solidFill>
-              <a:srgbClr val="E9E4D8"/>
-            </a:solidFill>
-            <a:prstDash val="solid"/>
-          </a:ln>
-        </p:spPr>
-        <p:style>
-          <a:lnRef xmlns:a="http://schemas.openxmlformats.org/drawingml/2006/main" idx="0"/>
-          <a:fillRef xmlns:a="http://schemas.openxmlformats.org/drawingml/2006/main" idx="0"/>
-          <a:effectRef xmlns:a="http://schemas.openxmlformats.org/drawingml/2006/main" idx="4"/>
-          <a:fontRef xmlns:a="http://schemas.openxmlformats.org/drawingml/2006/main" idx="major"/>
-        </p:style>
-      </p:sp>
-      <p:sp>
-        <p:nvSpPr>
-          <p:cNvPr id="8" name="">
-            <a:extLst xmlns:a="http://schemas.openxmlformats.org/drawingml/2006/main">
-              <a:ext uri="{FF2B5EF4-FFF2-40B4-BE49-F238E27FC236}">
-                <a16:creationId xmlns:a16="http://schemas.microsoft.com/office/drawing/2014/main" id="{4442AD6D-37AA-477F-AD03-081344F794F3}"/>
-              </a:ext>
-            </a:extLst>
-          </p:cNvPr>
-          <p:cNvSpPr>
-            <a:spLocks xmlns:a="http://schemas.openxmlformats.org/drawingml/2006/main" noGrp="1"/>
-          </p:cNvSpPr>
-          <p:nvPr/>
-        </p:nvSpPr>
-        <p:spPr>
-          <a:xfrm xmlns:a="http://schemas.openxmlformats.org/drawingml/2006/main">
-            <a:off x="7810500" y="2181225"/>
-            <a:ext cx="76200" cy="1485900"/>
-          </a:xfrm>
-          <a:prstGeom xmlns:a="http://schemas.openxmlformats.org/drawingml/2006/main" prst="rect">
-            <a:avLst/>
-          </a:prstGeom>
-          <a:solidFill xmlns:a="http://schemas.openxmlformats.org/drawingml/2006/main">
-            <a:srgbClr val="007C77"/>
-          </a:solidFill>
-          <a:ln xmlns:a="http://schemas.openxmlformats.org/drawingml/2006/main" w="0">
-            <a:solidFill>
-              <a:srgbClr val="007C77"/>
-            </a:solidFill>
-            <a:prstDash val="solid"/>
-          </a:ln>
-        </p:spPr>
-      </p:sp>
-      <p:sp>
-        <p:nvSpPr>
-          <p:cNvPr id="9" name="">
-            <a:extLst xmlns:a="http://schemas.openxmlformats.org/drawingml/2006/main">
-              <a:ext uri="{FF2B5EF4-FFF2-40B4-BE49-F238E27FC236}">
-                <a16:creationId xmlns:a16="http://schemas.microsoft.com/office/drawing/2014/main" id="{556FA892-446F-461D-9550-614CF4C19631}"/>
-              </a:ext>
-            </a:extLst>
-          </p:cNvPr>
-          <p:cNvSpPr>
-            <a:spLocks xmlns:a="http://schemas.openxmlformats.org/drawingml/2006/main" noGrp="1"/>
-          </p:cNvSpPr>
-          <p:nvPr/>
-        </p:nvSpPr>
-        <p:spPr>
-          <a:xfrm xmlns:a="http://schemas.openxmlformats.org/drawingml/2006/main">
-            <a:off x="8058150" y="2371725"/>
-            <a:ext cx="3371850" cy="361950"/>
-          </a:xfrm>
-          <a:prstGeom xmlns:a="http://schemas.openxmlformats.org/drawingml/2006/main" prst="rect">
-            <a:avLst/>
-          </a:prstGeom>
-          <a:noFill xmlns:a="http://schemas.openxmlformats.org/drawingml/2006/main"/>
-          <a:ln xmlns:a="http://schemas.openxmlformats.org/drawingml/2006/main" w="0">
-            <a:noFill/>
-            <a:prstDash val="solid"/>
-          </a:ln>
-        </p:spPr>
-        <p:txBody>
-          <a:bodyPr xmlns:a="http://schemas.openxmlformats.org/drawingml/2006/main" lIns="0" tIns="0" rIns="0" bIns="0" anchor="t">
-            <a:normAutofit fontScale="100000"/>
-          </a:bodyPr>
-          <a:lstStyle xmlns:a="http://schemas.openxmlformats.org/drawingml/2006/main"/>
-          <a:p xmlns:a="http://schemas.openxmlformats.org/drawingml/2006/main">
-            <a:pPr>
-              <a:buNone/>
-              <a:defRPr sz="1725" b="1">
-                <a:solidFill>
-                  <a:srgbClr val="14213D"/>
-                </a:solidFill>
-                <a:latin typeface="Georgia"/>
-                <a:ea typeface="Georgia"/>
-                <a:cs typeface="Georgia"/>
-              </a:defRPr>
-            </a:pPr>
-            <a:r>
-              <a:rPr sz="1725" b="1">
-                <a:solidFill>
-                  <a:srgbClr val="14213D"/>
-                </a:solidFill>
-                <a:latin typeface="Georgia"/>
-                <a:ea typeface="Georgia"/>
-                <a:cs typeface="Georgia"/>
-              </a:rPr>
-              <a:t>Atlas layer</a:t>
-            </a:r>
-          </a:p>
-        </p:txBody>
-      </p:sp>
-      <p:sp>
-        <p:nvSpPr>
-          <p:cNvPr id="10" name="">
-            <a:extLst xmlns:a="http://schemas.openxmlformats.org/drawingml/2006/main">
-              <a:ext uri="{FF2B5EF4-FFF2-40B4-BE49-F238E27FC236}">
-                <a16:creationId xmlns:a16="http://schemas.microsoft.com/office/drawing/2014/main" id="{F86B820A-35C1-4678-B006-C74EBAC48107}"/>
-              </a:ext>
-            </a:extLst>
-          </p:cNvPr>
-          <p:cNvSpPr>
-            <a:spLocks xmlns:a="http://schemas.openxmlformats.org/drawingml/2006/main" noGrp="1"/>
-          </p:cNvSpPr>
-          <p:nvPr/>
-        </p:nvSpPr>
-        <p:spPr>
-          <a:xfrm xmlns:a="http://schemas.openxmlformats.org/drawingml/2006/main">
-            <a:off x="8058150" y="2819400"/>
-            <a:ext cx="3371850" cy="647700"/>
-          </a:xfrm>
-          <a:prstGeom xmlns:a="http://schemas.openxmlformats.org/drawingml/2006/main" prst="rect">
-            <a:avLst/>
-          </a:prstGeom>
-          <a:noFill xmlns:a="http://schemas.openxmlformats.org/drawingml/2006/main"/>
-          <a:ln xmlns:a="http://schemas.openxmlformats.org/drawingml/2006/main" w="0">
-            <a:noFill/>
-            <a:prstDash val="solid"/>
-          </a:ln>
-        </p:spPr>
-        <p:txBody>
-          <a:bodyPr xmlns:a="http://schemas.openxmlformats.org/drawingml/2006/main" lIns="0" tIns="0" rIns="0" bIns="0" anchor="t">
-            <a:normAutofit fontScale="100000"/>
-          </a:bodyPr>
-          <a:lstStyle xmlns:a="http://schemas.openxmlformats.org/drawingml/2006/main"/>
-          <a:p xmlns:a="http://schemas.openxmlformats.org/drawingml/2006/main">
-            <a:pPr>
-              <a:lnSpc>
-                <a:spcPct val="115000"/>
-              </a:lnSpc>
-              <a:buNone/>
-              <a:defRPr sz="1425">
-                <a:solidFill>
-                  <a:srgbClr val="5C6577"/>
-                </a:solidFill>
-                <a:latin typeface="Avenir Next"/>
-                <a:ea typeface="Avenir Next"/>
-                <a:cs typeface="Avenir Next"/>
-              </a:defRPr>
-            </a:pPr>
-            <a:r>
-              <a:rPr sz="1425">
-                <a:solidFill>
-                  <a:srgbClr val="5C6577"/>
-                </a:solidFill>
-                <a:latin typeface="Avenir Next"/>
-                <a:ea typeface="Avenir Next"/>
-                <a:cs typeface="Avenir Next"/>
-              </a:rPr>
-              <a:t>Project · cluster · network access · database users · logs</a:t>
-            </a:r>
-          </a:p>
-        </p:txBody>
-      </p:sp>
-      <p:sp>
-        <p:nvSpPr>
-          <p:cNvPr id="11" name="">
-            <a:extLst xmlns:a="http://schemas.openxmlformats.org/drawingml/2006/main">
-              <a:ext uri="{FF2B5EF4-FFF2-40B4-BE49-F238E27FC236}">
-                <a16:creationId xmlns:a16="http://schemas.microsoft.com/office/drawing/2014/main" id="{647E7C82-8C55-4563-A917-2628102B5569}"/>
-              </a:ext>
-            </a:extLst>
-          </p:cNvPr>
-          <p:cNvSpPr>
-            <a:spLocks xmlns:a="http://schemas.openxmlformats.org/drawingml/2006/main" noGrp="1"/>
-          </p:cNvSpPr>
-          <p:nvPr/>
-        </p:nvSpPr>
-        <p:spPr>
-          <a:xfrm xmlns:a="http://schemas.openxmlformats.org/drawingml/2006/main">
-            <a:off x="7810500" y="4000500"/>
-            <a:ext cx="3829050" cy="1485900"/>
-          </a:xfrm>
-          <a:prstGeom xmlns:a="http://schemas.openxmlformats.org/drawingml/2006/main" prst="roundRect">
-            <a:avLst>
-              <a:gd name="adj" fmla="val 11538"/>
-            </a:avLst>
-          </a:prstGeom>
-          <a:solidFill xmlns:a="http://schemas.openxmlformats.org/drawingml/2006/main">
-            <a:srgbClr val="FFF8EE"/>
-          </a:solidFill>
-          <a:ln xmlns:a="http://schemas.openxmlformats.org/drawingml/2006/main" w="9525">
-            <a:solidFill>
-              <a:srgbClr val="E9E4D8"/>
-            </a:solidFill>
-            <a:prstDash val="solid"/>
-          </a:ln>
-        </p:spPr>
-        <p:style>
-          <a:lnRef xmlns:a="http://schemas.openxmlformats.org/drawingml/2006/main" idx="0"/>
-          <a:fillRef xmlns:a="http://schemas.openxmlformats.org/drawingml/2006/main" idx="0"/>
-          <a:effectRef xmlns:a="http://schemas.openxmlformats.org/drawingml/2006/main" idx="4"/>
-          <a:fontRef xmlns:a="http://schemas.openxmlformats.org/drawingml/2006/main" idx="major"/>
-        </p:style>
-      </p:sp>
-      <p:sp>
-        <p:nvSpPr>
-          <p:cNvPr id="12" name="">
-            <a:extLst xmlns:a="http://schemas.openxmlformats.org/drawingml/2006/main">
-              <a:ext uri="{FF2B5EF4-FFF2-40B4-BE49-F238E27FC236}">
-                <a16:creationId xmlns:a16="http://schemas.microsoft.com/office/drawing/2014/main" id="{3DEFC58E-7651-4407-85B2-30C17A8CEE88}"/>
-              </a:ext>
-            </a:extLst>
-          </p:cNvPr>
-          <p:cNvSpPr>
-            <a:spLocks xmlns:a="http://schemas.openxmlformats.org/drawingml/2006/main" noGrp="1"/>
-          </p:cNvSpPr>
-          <p:nvPr/>
-        </p:nvSpPr>
-        <p:spPr>
-          <a:xfrm xmlns:a="http://schemas.openxmlformats.org/drawingml/2006/main">
-            <a:off x="7810500" y="4000500"/>
-            <a:ext cx="76200" cy="1485900"/>
-          </a:xfrm>
-          <a:prstGeom xmlns:a="http://schemas.openxmlformats.org/drawingml/2006/main" prst="rect">
-            <a:avLst/>
-          </a:prstGeom>
-          <a:solidFill xmlns:a="http://schemas.openxmlformats.org/drawingml/2006/main">
-            <a:srgbClr val="F4A261"/>
-          </a:solidFill>
-          <a:ln xmlns:a="http://schemas.openxmlformats.org/drawingml/2006/main" w="0">
-            <a:solidFill>
-              <a:srgbClr val="F4A261"/>
-            </a:solidFill>
-            <a:prstDash val="solid"/>
-          </a:ln>
-        </p:spPr>
-      </p:sp>
-      <p:sp>
-        <p:nvSpPr>
-          <p:cNvPr id="13" name="">
-            <a:extLst xmlns:a="http://schemas.openxmlformats.org/drawingml/2006/main">
-              <a:ext uri="{FF2B5EF4-FFF2-40B4-BE49-F238E27FC236}">
-                <a16:creationId xmlns:a16="http://schemas.microsoft.com/office/drawing/2014/main" id="{D4548902-7F7A-45BB-AA68-CB7E2EC852FB}"/>
-              </a:ext>
-            </a:extLst>
-          </p:cNvPr>
-          <p:cNvSpPr>
-            <a:spLocks xmlns:a="http://schemas.openxmlformats.org/drawingml/2006/main" noGrp="1"/>
-          </p:cNvSpPr>
-          <p:nvPr/>
-        </p:nvSpPr>
-        <p:spPr>
-          <a:xfrm xmlns:a="http://schemas.openxmlformats.org/drawingml/2006/main">
-            <a:off x="8058150" y="4191000"/>
-            <a:ext cx="3371850" cy="361950"/>
-          </a:xfrm>
-          <a:prstGeom xmlns:a="http://schemas.openxmlformats.org/drawingml/2006/main" prst="rect">
-            <a:avLst/>
-          </a:prstGeom>
-          <a:noFill xmlns:a="http://schemas.openxmlformats.org/drawingml/2006/main"/>
-          <a:ln xmlns:a="http://schemas.openxmlformats.org/drawingml/2006/main" w="0">
-            <a:noFill/>
-            <a:prstDash val="solid"/>
-          </a:ln>
-        </p:spPr>
-        <p:txBody>
-          <a:bodyPr xmlns:a="http://schemas.openxmlformats.org/drawingml/2006/main" lIns="0" tIns="0" rIns="0" bIns="0" anchor="t">
-            <a:normAutofit fontScale="100000"/>
-          </a:bodyPr>
-          <a:lstStyle xmlns:a="http://schemas.openxmlformats.org/drawingml/2006/main"/>
-          <a:p xmlns:a="http://schemas.openxmlformats.org/drawingml/2006/main">
-            <a:pPr>
-              <a:buNone/>
-              <a:defRPr sz="1725" b="1">
-                <a:solidFill>
-                  <a:srgbClr val="14213D"/>
-                </a:solidFill>
-                <a:latin typeface="Georgia"/>
-                <a:ea typeface="Georgia"/>
-                <a:cs typeface="Georgia"/>
-              </a:defRPr>
-            </a:pPr>
-            <a:r>
-              <a:rPr sz="1725" b="1">
-                <a:solidFill>
-                  <a:srgbClr val="14213D"/>
-                </a:solidFill>
-                <a:latin typeface="Georgia"/>
-                <a:ea typeface="Georgia"/>
-                <a:cs typeface="Georgia"/>
-              </a:rPr>
-              <a:t>MongoDB layer</a:t>
-            </a:r>
-          </a:p>
-        </p:txBody>
-      </p:sp>
-      <p:sp>
-        <p:nvSpPr>
-          <p:cNvPr id="14" name="">
-            <a:extLst xmlns:a="http://schemas.openxmlformats.org/drawingml/2006/main">
-              <a:ext uri="{FF2B5EF4-FFF2-40B4-BE49-F238E27FC236}">
-                <a16:creationId xmlns:a16="http://schemas.microsoft.com/office/drawing/2014/main" id="{E2801D96-4D9E-44A5-B7C6-661E9F9A05A9}"/>
-              </a:ext>
-            </a:extLst>
-          </p:cNvPr>
-          <p:cNvSpPr>
-            <a:spLocks xmlns:a="http://schemas.openxmlformats.org/drawingml/2006/main" noGrp="1"/>
-          </p:cNvSpPr>
-          <p:nvPr/>
-        </p:nvSpPr>
-        <p:spPr>
-          <a:xfrm xmlns:a="http://schemas.openxmlformats.org/drawingml/2006/main">
-            <a:off x="8058150" y="4638675"/>
-            <a:ext cx="3371850" cy="647700"/>
-          </a:xfrm>
-          <a:prstGeom xmlns:a="http://schemas.openxmlformats.org/drawingml/2006/main" prst="rect">
-            <a:avLst/>
-          </a:prstGeom>
-          <a:noFill xmlns:a="http://schemas.openxmlformats.org/drawingml/2006/main"/>
-          <a:ln xmlns:a="http://schemas.openxmlformats.org/drawingml/2006/main" w="0">
-            <a:noFill/>
-            <a:prstDash val="solid"/>
-          </a:ln>
-        </p:spPr>
-        <p:txBody>
-          <a:bodyPr xmlns:a="http://schemas.openxmlformats.org/drawingml/2006/main" lIns="0" tIns="0" rIns="0" bIns="0" anchor="t">
-            <a:normAutofit fontScale="100000"/>
-          </a:bodyPr>
-          <a:lstStyle xmlns:a="http://schemas.openxmlformats.org/drawingml/2006/main"/>
-          <a:p xmlns:a="http://schemas.openxmlformats.org/drawingml/2006/main">
-            <a:pPr>
-              <a:lnSpc>
-                <a:spcPct val="115000"/>
-              </a:lnSpc>
-              <a:buNone/>
-              <a:defRPr sz="1425">
-                <a:solidFill>
-                  <a:srgbClr val="5C6577"/>
-                </a:solidFill>
-                <a:latin typeface="Avenir Next"/>
-                <a:ea typeface="Avenir Next"/>
-                <a:cs typeface="Avenir Next"/>
-              </a:defRPr>
-            </a:pPr>
-            <a:r>
-              <a:rPr sz="1425">
-                <a:solidFill>
-                  <a:srgbClr val="5C6577"/>
-                </a:solidFill>
-                <a:latin typeface="Avenir Next"/>
-                <a:ea typeface="Avenir Next"/>
-                <a:cs typeface="Avenir Next"/>
-              </a:rPr>
-              <a:t>Databases · collections · BSON documents · queries · indexes</a:t>
-            </a:r>
-          </a:p>
-        </p:txBody>
-      </p:sp>
-      <p:sp>
-        <p:nvSpPr>
-          <p:cNvPr id="15" name="">
-            <a:extLst xmlns:a="http://schemas.openxmlformats.org/drawingml/2006/main">
-              <a:ext uri="{FF2B5EF4-FFF2-40B4-BE49-F238E27FC236}">
-                <a16:creationId xmlns:a16="http://schemas.microsoft.com/office/drawing/2014/main" id="{9A1E3507-E43F-4957-B019-5419EE166FAC}"/>
-              </a:ext>
-            </a:extLst>
-          </p:cNvPr>
-          <p:cNvSpPr>
-            <a:spLocks xmlns:a="http://schemas.openxmlformats.org/drawingml/2006/main" noGrp="1"/>
-          </p:cNvSpPr>
-          <p:nvPr/>
-        </p:nvSpPr>
-        <p:spPr>
-          <a:xfrm xmlns:a="http://schemas.openxmlformats.org/drawingml/2006/main">
-            <a:off x="7943850" y="5772150"/>
-            <a:ext cx="3429000" cy="400050"/>
-          </a:xfrm>
-          <a:prstGeom xmlns:a="http://schemas.openxmlformats.org/drawingml/2006/main" prst="rect">
-            <a:avLst/>
-          </a:prstGeom>
-          <a:noFill xmlns:a="http://schemas.openxmlformats.org/drawingml/2006/main"/>
-          <a:ln xmlns:a="http://schemas.openxmlformats.org/drawingml/2006/main" w="0">
-            <a:noFill/>
-            <a:prstDash val="solid"/>
-          </a:ln>
-        </p:spPr>
-        <p:txBody>
-          <a:bodyPr xmlns:a="http://schemas.openxmlformats.org/drawingml/2006/main" wrap="square" lIns="0" tIns="0" rIns="0" bIns="0" anchor="t">
-            <a:noAutofit/>
-          </a:bodyPr>
-          <a:lstStyle xmlns:a="http://schemas.openxmlformats.org/drawingml/2006/main"/>
-          <a:p xmlns:a="http://schemas.openxmlformats.org/drawingml/2006/main">
-            <a:pPr algn="ctr">
-              <a:buNone/>
-              <a:defRPr sz="1275" b="0">
-                <a:solidFill>
-                  <a:srgbClr val="5C6577"/>
-                </a:solidFill>
-                <a:latin typeface="Avenir Next"/>
-                <a:ea typeface="Avenir Next"/>
-                <a:cs typeface="Avenir Next"/>
-              </a:defRPr>
-            </a:pPr>
-            <a:r>
-              <a:rPr sz="1275" b="0">
-                <a:solidFill>
-                  <a:srgbClr val="5C6577"/>
-                </a:solidFill>
-                <a:latin typeface="Avenir Next"/>
-                <a:ea typeface="Avenir Next"/>
-                <a:cs typeface="Avenir Next"/>
-              </a:rPr>
-              <a:t>Dated interface example. No cloud account is needed for this week's lab.</a:t>
-            </a:r>
-          </a:p>
-        </p:txBody>
-      </p:sp>
-    </p:spTree>
-    <p:extLst>
-      <p:ext uri="{BB962C8B-B14F-4D97-AF65-F5344CB8AC3E}">
-        <p14:creationId xmlns:p14="http://schemas.microsoft.com/office/powerpoint/2010/main" val="507522520"/>
-      </p:ext>
-    </p:extLst>
-  </p:cSld>
-</p:sld>
+<ns0:sld xmlns:ns0="http://schemas.openxmlformats.org/presentationml/2006/main" xmlns:ns1="http://schemas.openxmlformats.org/drawingml/2006/main" xmlns:ns2="http://schemas.microsoft.com/office/drawing/2014/main" xmlns:ns3="http://schemas.openxmlformats.org/officeDocument/2006/relationships" xmlns:ns4="http://schemas.microsoft.com/office/powerpoint/2010/main">
+  <ns0:cSld>
+    <ns0:bg>
+      <ns0:bgPr>
+        <ns1:solidFill>
+          <ns1:srgbClr val="F7F3EA"/>
+        </ns1:solidFill>
+      </ns0:bgPr>
+    </ns0:bg>
+    <ns0:spTree>
+      <ns0:nvGrpSpPr>
+        <ns0:cNvPr id="1" name=""/>
+        <ns0:cNvGrpSpPr/>
+        <ns0:nvPr/>
+      </ns0:nvGrpSpPr>
+      <ns0:grpSpPr>
+        <ns1:xfrm/>
+      </ns0:grpSpPr>
+      <ns0:sp>
+        <ns0:nvSpPr>
+          <ns0:cNvPr id="16" name="">
+            <ns1:extLst>
+              <ns1:ext uri="{FF2B5EF4-FFF2-40B4-BE49-F238E27FC236}">
+                <ns2:creationId id="{31896894-5F88-4FA0-B8F7-A3B9556AC8AA}"/>
+              </ns1:ext>
+            </ns1:extLst>
+          </ns0:cNvPr>
+          <ns0:cNvSpPr>
+            <ns1:spLocks noGrp="1"/>
+          </ns0:cNvSpPr>
+          <ns0:nvPr/>
+        </ns0:nvSpPr>
+        <ns0:spPr>
+          <ns1:xfrm>
+            <ns1:off x="552450" y="400050"/>
+            <ns1:ext cx="1447800" cy="323850"/>
+          </ns1:xfrm>
+          <ns1:prstGeom prst="roundRect">
+            <ns1:avLst>
+              <ns1:gd name="adj" fmla="val 50000"/>
+            </ns1:avLst>
+          </ns1:prstGeom>
+          <ns1:solidFill>
+            <ns1:srgbClr val="14213D"/>
+          </ns1:solidFill>
+          <ns1:ln w="9525">
+            <ns1:solidFill>
+              <ns1:srgbClr val="14213D"/>
+            </ns1:solidFill>
+            <ns1:prstDash val="solid"/>
+          </ns1:ln>
+        </ns0:spPr>
+        <ns0:txBody>
+          <ns1:bodyPr lIns="76200" tIns="0" rIns="76200" bIns="0" anchor="ctr">
+            <ns1:normAutofit fontScale="96996"/>
+          </ns1:bodyPr>
+          <ns1:lstStyle/>
+          <ns1:p>
+            <ns1:pPr algn="ctr">
+              <ns1:buNone/>
+              <ns1:defRPr sz="1050" b="1">
+                <ns1:solidFill>
+                  <ns1:srgbClr val="FFFFFF"/>
+                </ns1:solidFill>
+                <ns1:latin typeface="Avenir Next"/>
+                <ns1:ea typeface="Avenir Next"/>
+                <ns1:cs typeface="Avenir Next"/>
+              </ns1:defRPr>
+            </ns1:pPr>
+            <ns1:r>
+              <ns1:rPr sz="1050" b="1">
+                <ns1:solidFill>
+                  <ns1:srgbClr val="FFFFFF"/>
+                </ns1:solidFill>
+                <ns1:latin typeface="Avenir Next"/>
+                <ns1:ea typeface="Avenir Next"/>
+                <ns1:cs typeface="Avenir Next"/>
+              </ns1:rPr>
+              <ns1:t>CLOUD INTERFACE</ns1:t>
+            </ns1:r>
+          </ns1:p>
+        </ns0:txBody>
+      </ns0:sp>
+      <ns0:sp>
+        <ns0:nvSpPr>
+          <ns0:cNvPr id="2" name="slide-title">
+            <ns1:extLst>
+              <ns1:ext uri="{FF2B5EF4-FFF2-40B4-BE49-F238E27FC236}">
+                <ns2:creationId id="{88388ED0-F419-4FDC-A263-1289F17C48A1}"/>
+              </ns1:ext>
+            </ns1:extLst>
+          </ns0:cNvPr>
+          <ns0:cNvSpPr>
+            <ns1:spLocks noGrp="1"/>
+          </ns0:cNvSpPr>
+          <ns0:nvPr/>
+        </ns0:nvSpPr>
+        <ns0:spPr>
+          <ns1:xfrm>
+            <ns1:off x="552450" y="876300"/>
+            <ns1:ext cx="11087100" cy="704850"/>
+          </ns1:xfrm>
+          <ns1:prstGeom prst="rect">
+            <ns1:avLst/>
+          </ns1:prstGeom>
+          <ns1:noFill/>
+          <ns1:ln w="0">
+            <ns1:noFill/>
+            <ns1:prstDash val="solid"/>
+          </ns1:ln>
+        </ns0:spPr>
+        <ns0:txBody>
+          <ns1:bodyPr lIns="0" tIns="0" rIns="0" bIns="0" anchor="t">
+            <ns1:normAutofit fontScale="100000"/>
+          </ns1:bodyPr>
+          <ns1:lstStyle/>
+          <ns1:p>
+            <ns1:pPr>
+              <ns1:lnSpc>
+                <ns1:spcPct val="95000"/>
+              </ns1:lnSpc>
+              <ns1:buNone/>
+              <ns1:defRPr sz="3000" b="1">
+                <ns1:solidFill>
+                  <ns1:srgbClr val="14213D"/>
+                </ns1:solidFill>
+                <ns1:latin typeface="Georgia"/>
+                <ns1:ea typeface="Georgia"/>
+                <ns1:cs typeface="Georgia"/>
+              </ns1:defRPr>
+            </ns1:pPr>
+            <ns1:r>
+              <ns1:rPr sz="3000" b="1">
+                <ns1:solidFill>
+                  <ns1:srgbClr val="14213D"/>
+                </ns1:solidFill>
+                <ns1:latin typeface="Georgia"/>
+                <ns1:ea typeface="Georgia"/>
+                <ns1:cs typeface="Georgia"/>
+              </ns1:rPr>
+              <ns1:t>MongoDB Atlas operates MongoDB in the cloud</ns1:t>
+            </ns1:r>
+          </ns1:p>
+        </ns0:txBody>
+      </ns0:sp>
+      <ns0:sp>
+        <ns0:nvSpPr>
+          <ns0:cNvPr id="3" name="">
+            <ns1:extLst>
+              <ns1:ext uri="{FF2B5EF4-FFF2-40B4-BE49-F238E27FC236}">
+                <ns2:creationId id="{D26C06D8-0780-4513-AB3F-492DC56C46AA}"/>
+              </ns1:ext>
+            </ns1:extLst>
+          </ns0:cNvPr>
+          <ns0:cNvSpPr>
+            <ns1:spLocks noGrp="1"/>
+          </ns0:cNvSpPr>
+          <ns0:nvPr/>
+        </ns0:nvSpPr>
+        <ns0:spPr>
+          <ns1:xfrm>
+            <ns1:off x="571500" y="1562100"/>
+            <ns1:ext cx="10477500" cy="381000"/>
+          </ns1:xfrm>
+          <ns1:prstGeom prst="rect">
+            <ns1:avLst/>
+          </ns1:prstGeom>
+          <ns1:noFill/>
+          <ns1:ln w="0">
+            <ns1:noFill/>
+            <ns1:prstDash val="solid"/>
+          </ns1:ln>
+        </ns0:spPr>
+        <ns0:txBody>
+          <ns1:bodyPr lIns="0" tIns="0" rIns="0" bIns="0" anchor="t">
+            <ns1:normAutofit fontScale="100000"/>
+          </ns1:bodyPr>
+          <ns1:lstStyle/>
+          <ns1:p>
+            <ns1:pPr>
+              <ns1:buNone/>
+              <ns1:defRPr sz="1425">
+                <ns1:solidFill>
+                  <ns1:srgbClr val="5C6577"/>
+                </ns1:solidFill>
+                <ns1:latin typeface="Avenir Next"/>
+                <ns1:ea typeface="Avenir Next"/>
+                <ns1:cs typeface="Avenir Next"/>
+              </ns1:defRPr>
+            </ns1:pPr>
+            <ns1:r>
+              <ns1:rPr sz="1425">
+                <ns1:solidFill>
+                  <ns1:srgbClr val="5C6577"/>
+                </ns1:solidFill>
+                <ns1:latin typeface="Avenir Next"/>
+                <ns1:ea typeface="Avenir Next"/>
+                <ns1:cs typeface="Avenir Next"/>
+              </ns1:rPr>
+              <ns1:t>Projects, clusters, users, network rules, and data tools surround the document database.</ns1:t>
+            </ns1:r>
+          </ns1:p>
+        </ns0:txBody>
+      </ns0:sp>
+      <ns0:sp>
+        <ns0:nvSpPr>
+          <ns0:cNvPr id="4" name="">
+            <ns1:extLst>
+              <ns1:ext uri="{FF2B5EF4-FFF2-40B4-BE49-F238E27FC236}">
+                <ns2:creationId id="{4D4F6477-AD3C-41DA-A4AD-841179DE5AE4}"/>
+              </ns1:ext>
+            </ns1:extLst>
+          </ns0:cNvPr>
+          <ns0:cNvSpPr>
+            <ns1:spLocks noGrp="1"/>
+          </ns0:cNvSpPr>
+          <ns0:nvPr/>
+        </ns0:nvSpPr>
+        <ns0:spPr>
+          <ns1:xfrm>
+            <ns1:off x="11144250" y="6334125"/>
+            <ns1:ext cx="495300" cy="228600"/>
+          </ns1:xfrm>
+          <ns1:prstGeom prst="rect">
+            <ns1:avLst/>
+          </ns1:prstGeom>
+          <ns1:noFill/>
+          <ns1:ln w="0">
+            <ns1:noFill/>
+            <ns1:prstDash val="solid"/>
+          </ns1:ln>
+        </ns0:spPr>
+        <ns0:txBody>
+          <ns1:bodyPr wrap="square" lIns="0" tIns="0" rIns="0" bIns="0" anchor="t">
+            <ns1:noAutofit/>
+          </ns1:bodyPr>
+          <ns1:lstStyle/>
+          <ns1:p>
+            <ns1:pPr algn="r">
+              <ns1:buNone/>
+              <ns1:defRPr sz="1050" b="1">
+                <ns1:solidFill>
+                  <ns1:srgbClr val="5C6577"/>
+                </ns1:solidFill>
+                <ns1:latin typeface="Menlo"/>
+                <ns1:ea typeface="Menlo"/>
+                <ns1:cs typeface="Menlo"/>
+              </ns1:defRPr>
+            </ns1:pPr>
+            <ns1:r>
+              <ns1:rPr sz="1050" b="1">
+                <ns1:solidFill>
+                  <ns1:srgbClr val="5C6577"/>
+                </ns1:solidFill>
+                <ns1:latin typeface="Menlo"/>
+                <ns1:ea typeface="Menlo"/>
+                <ns1:cs typeface="Menlo"/>
+              </ns1:rPr>
+              <ns1:t>06</ns1:t>
+            </ns1:r>
+          </ns1:p>
+        </ns0:txBody>
+      </ns0:sp>
+      <ns0:sp>
+        <ns0:nvSpPr>
+          <ns0:cNvPr id="5" name="">
+            <ns1:extLst>
+              <ns1:ext uri="{FF2B5EF4-FFF2-40B4-BE49-F238E27FC236}">
+                <ns2:creationId id="{FCB0DB75-0A32-4F59-AF0F-4B76736744AB}"/>
+              </ns1:ext>
+            </ns1:extLst>
+          </ns0:cNvPr>
+          <ns0:cNvSpPr>
+            <ns1:spLocks noGrp="1"/>
+          </ns0:cNvSpPr>
+          <ns0:nvPr/>
+        </ns0:nvSpPr>
+        <ns0:spPr>
+          <ns1:xfrm>
+            <ns1:off x="552450" y="2038350"/>
+            <ns1:ext cx="6858000" cy="4095750"/>
+          </ns1:xfrm>
+          <ns1:prstGeom prst="roundRect">
+            <ns1:avLst>
+              <ns1:gd name="adj" fmla="val 4186"/>
+            </ns1:avLst>
+          </ns1:prstGeom>
+          <ns1:solidFill>
+            <ns1:srgbClr val="FFFFFF"/>
+          </ns1:solidFill>
+          <ns1:ln w="9525">
+            <ns1:solidFill>
+              <ns1:srgbClr val="E9E4D8"/>
+            </ns1:solidFill>
+            <ns1:prstDash val="solid"/>
+          </ns1:ln>
+        </ns0:spPr>
+      </ns0:sp>
+      <ns0:pic>
+        <ns0:nvPicPr>
+          <ns0:cNvPr id="23" name="" descr="MongoDB Atlas project overview, captured August 25, 2026 with account details redacted. A free cluster has Connect, Add data, and Load sample data controls. The left navigation includes Data Explorer and Database and Network Access. This dashboard manages the deployment; opening it does not establish a database-client connection."/>
+          <ns0:cNvPicPr>
+            <ns1:picLocks noChangeAspect="1"/>
+          </ns0:cNvPicPr>
+          <ns0:nvPr/>
+        </ns0:nvPicPr>
+        <ns0:blipFill>
+          <ns1:blip ns3:embed="R0487ba9696264a22"/>
+          <ns1:srcRect l="0" t="10087" r="0" b="10087"/>
+          <ns1:stretch>
+            <ns1:fillRect l="0" t="0" r="0" b="0"/>
+          </ns1:stretch>
+        </ns0:blipFill>
+        <ns0:spPr>
+          <ns1:xfrm>
+            <ns1:off x="695325" y="2171700"/>
+            <ns1:ext cx="6572250" cy="3810000"/>
+          </ns1:xfrm>
+          <ns1:prstGeom prst="roundRect">
+            <ns1:avLst>
+              <ns1:gd name="adj" fmla="val 3000"/>
+            </ns1:avLst>
+          </ns1:prstGeom>
+        </ns0:spPr>
+      </ns0:pic>
+      <ns0:sp>
+        <ns0:nvSpPr>
+          <ns0:cNvPr id="7" name="">
+            <ns1:extLst>
+              <ns1:ext uri="{FF2B5EF4-FFF2-40B4-BE49-F238E27FC236}">
+                <ns2:creationId id="{A91DD7FA-F4F5-4AC9-A03E-97B14698C09B}"/>
+              </ns1:ext>
+            </ns1:extLst>
+          </ns0:cNvPr>
+          <ns0:cNvSpPr>
+            <ns1:spLocks noGrp="1"/>
+          </ns0:cNvSpPr>
+          <ns0:nvPr/>
+        </ns0:nvSpPr>
+        <ns0:spPr>
+          <ns1:xfrm>
+            <ns1:off x="7810500" y="2181225"/>
+            <ns1:ext cx="3829050" cy="1485900"/>
+          </ns1:xfrm>
+          <ns1:prstGeom prst="roundRect">
+            <ns1:avLst>
+              <ns1:gd name="adj" fmla="val 11538"/>
+            </ns1:avLst>
+          </ns1:prstGeom>
+          <ns1:solidFill>
+            <ns1:srgbClr val="F1FBF8"/>
+          </ns1:solidFill>
+          <ns1:ln w="9525">
+            <ns1:solidFill>
+              <ns1:srgbClr val="E9E4D8"/>
+            </ns1:solidFill>
+            <ns1:prstDash val="solid"/>
+          </ns1:ln>
+        </ns0:spPr>
+        <ns0:style>
+          <ns1:lnRef idx="0"/>
+          <ns1:fillRef idx="0"/>
+          <ns1:effectRef idx="4"/>
+          <ns1:fontRef idx="major"/>
+        </ns0:style>
+      </ns0:sp>
+      <ns0:sp>
+        <ns0:nvSpPr>
+          <ns0:cNvPr id="8" name="">
+            <ns1:extLst>
+              <ns1:ext uri="{FF2B5EF4-FFF2-40B4-BE49-F238E27FC236}">
+                <ns2:creationId id="{4442AD6D-37AA-477F-AD03-081344F794F3}"/>
+              </ns1:ext>
+            </ns1:extLst>
+          </ns0:cNvPr>
+          <ns0:cNvSpPr>
+            <ns1:spLocks noGrp="1"/>
+          </ns0:cNvSpPr>
+          <ns0:nvPr/>
+        </ns0:nvSpPr>
+        <ns0:spPr>
+          <ns1:xfrm>
+            <ns1:off x="7810500" y="2181225"/>
+            <ns1:ext cx="76200" cy="1485900"/>
+          </ns1:xfrm>
+          <ns1:prstGeom prst="rect">
+            <ns1:avLst/>
+          </ns1:prstGeom>
+          <ns1:solidFill>
+            <ns1:srgbClr val="007C77"/>
+          </ns1:solidFill>
+          <ns1:ln w="0">
+            <ns1:solidFill>
+              <ns1:srgbClr val="007C77"/>
+            </ns1:solidFill>
+            <ns1:prstDash val="solid"/>
+          </ns1:ln>
+        </ns0:spPr>
+      </ns0:sp>
+      <ns0:sp>
+        <ns0:nvSpPr>
+          <ns0:cNvPr id="9" name="">
+            <ns1:extLst>
+              <ns1:ext uri="{FF2B5EF4-FFF2-40B4-BE49-F238E27FC236}">
+                <ns2:creationId id="{556FA892-446F-461D-9550-614CF4C19631}"/>
+              </ns1:ext>
+            </ns1:extLst>
+          </ns0:cNvPr>
+          <ns0:cNvSpPr>
+            <ns1:spLocks noGrp="1"/>
+          </ns0:cNvSpPr>
+          <ns0:nvPr/>
+        </ns0:nvSpPr>
+        <ns0:spPr>
+          <ns1:xfrm>
+            <ns1:off x="8058150" y="2371725"/>
+            <ns1:ext cx="3371850" cy="361950"/>
+          </ns1:xfrm>
+          <ns1:prstGeom prst="rect">
+            <ns1:avLst/>
+          </ns1:prstGeom>
+          <ns1:noFill/>
+          <ns1:ln w="0">
+            <ns1:noFill/>
+            <ns1:prstDash val="solid"/>
+          </ns1:ln>
+        </ns0:spPr>
+        <ns0:txBody>
+          <ns1:bodyPr lIns="0" tIns="0" rIns="0" bIns="0" anchor="t">
+            <ns1:normAutofit fontScale="100000"/>
+          </ns1:bodyPr>
+          <ns1:lstStyle/>
+          <ns1:p>
+            <ns1:pPr>
+              <ns1:buNone/>
+              <ns1:defRPr sz="1725" b="1">
+                <ns1:solidFill>
+                  <ns1:srgbClr val="14213D"/>
+                </ns1:solidFill>
+                <ns1:latin typeface="Georgia"/>
+                <ns1:ea typeface="Georgia"/>
+                <ns1:cs typeface="Georgia"/>
+              </ns1:defRPr>
+            </ns1:pPr>
+            <ns1:r>
+              <ns1:rPr sz="1725" b="1">
+                <ns1:solidFill>
+                  <ns1:srgbClr val="14213D"/>
+                </ns1:solidFill>
+                <ns1:latin typeface="Georgia"/>
+                <ns1:ea typeface="Georgia"/>
+                <ns1:cs typeface="Georgia"/>
+              </ns1:rPr>
+              <ns1:t>Atlas layer</ns1:t>
+            </ns1:r>
+          </ns1:p>
+        </ns0:txBody>
+      </ns0:sp>
+      <ns0:sp>
+        <ns0:nvSpPr>
+          <ns0:cNvPr id="10" name="">
+            <ns1:extLst>
+              <ns1:ext uri="{FF2B5EF4-FFF2-40B4-BE49-F238E27FC236}">
+                <ns2:creationId id="{F86B820A-35C1-4678-B006-C74EBAC48107}"/>
+              </ns1:ext>
+            </ns1:extLst>
+          </ns0:cNvPr>
+          <ns0:cNvSpPr>
+            <ns1:spLocks noGrp="1"/>
+          </ns0:cNvSpPr>
+          <ns0:nvPr/>
+        </ns0:nvSpPr>
+        <ns0:spPr>
+          <ns1:xfrm>
+            <ns1:off x="8058150" y="2819400"/>
+            <ns1:ext cx="3371850" cy="647700"/>
+          </ns1:xfrm>
+          <ns1:prstGeom prst="rect">
+            <ns1:avLst/>
+          </ns1:prstGeom>
+          <ns1:noFill/>
+          <ns1:ln w="0">
+            <ns1:noFill/>
+            <ns1:prstDash val="solid"/>
+          </ns1:ln>
+        </ns0:spPr>
+        <ns0:txBody>
+          <ns1:bodyPr lIns="0" tIns="0" rIns="0" bIns="0" anchor="t">
+            <ns1:normAutofit fontScale="100000"/>
+          </ns1:bodyPr>
+          <ns1:lstStyle/>
+          <ns1:p>
+            <ns1:pPr>
+              <ns1:lnSpc>
+                <ns1:spcPct val="115000"/>
+              </ns1:lnSpc>
+              <ns1:buNone/>
+              <ns1:defRPr sz="1425">
+                <ns1:solidFill>
+                  <ns1:srgbClr val="5C6577"/>
+                </ns1:solidFill>
+                <ns1:latin typeface="Avenir Next"/>
+                <ns1:ea typeface="Avenir Next"/>
+                <ns1:cs typeface="Avenir Next"/>
+              </ns1:defRPr>
+            </ns1:pPr>
+            <ns1:r>
+              <ns1:rPr sz="1425">
+                <ns1:solidFill>
+                  <ns1:srgbClr val="5C6577"/>
+                </ns1:solidFill>
+                <ns1:latin typeface="Avenir Next"/>
+                <ns1:ea typeface="Avenir Next"/>
+                <ns1:cs typeface="Avenir Next"/>
+              </ns1:rPr>
+              <ns1:t>Project · cluster · network access · database users · logs</ns1:t>
+            </ns1:r>
+          </ns1:p>
+        </ns0:txBody>
+      </ns0:sp>
+      <ns0:sp>
+        <ns0:nvSpPr>
+          <ns0:cNvPr id="11" name="">
+            <ns1:extLst>
+              <ns1:ext uri="{FF2B5EF4-FFF2-40B4-BE49-F238E27FC236}">
+                <ns2:creationId id="{647E7C82-8C55-4563-A917-2628102B5569}"/>
+              </ns1:ext>
+            </ns1:extLst>
+          </ns0:cNvPr>
+          <ns0:cNvSpPr>
+            <ns1:spLocks noGrp="1"/>
+          </ns0:cNvSpPr>
+          <ns0:nvPr/>
+        </ns0:nvSpPr>
+        <ns0:spPr>
+          <ns1:xfrm>
+            <ns1:off x="7810500" y="4000500"/>
+            <ns1:ext cx="3829050" cy="1485900"/>
+          </ns1:xfrm>
+          <ns1:prstGeom prst="roundRect">
+            <ns1:avLst>
+              <ns1:gd name="adj" fmla="val 11538"/>
+            </ns1:avLst>
+          </ns1:prstGeom>
+          <ns1:solidFill>
+            <ns1:srgbClr val="FFF8EE"/>
+          </ns1:solidFill>
+          <ns1:ln w="9525">
+            <ns1:solidFill>
+              <ns1:srgbClr val="E9E4D8"/>
+            </ns1:solidFill>
+            <ns1:prstDash val="solid"/>
+          </ns1:ln>
+        </ns0:spPr>
+        <ns0:style>
+          <ns1:lnRef idx="0"/>
+          <ns1:fillRef idx="0"/>
+          <ns1:effectRef idx="4"/>
+          <ns1:fontRef idx="major"/>
+        </ns0:style>
+      </ns0:sp>
+      <ns0:sp>
+        <ns0:nvSpPr>
+          <ns0:cNvPr id="12" name="">
+            <ns1:extLst>
+              <ns1:ext uri="{FF2B5EF4-FFF2-40B4-BE49-F238E27FC236}">
+                <ns2:creationId id="{3DEFC58E-7651-4407-85B2-30C17A8CEE88}"/>
+              </ns1:ext>
+            </ns1:extLst>
+          </ns0:cNvPr>
+          <ns0:cNvSpPr>
+            <ns1:spLocks noGrp="1"/>
+          </ns0:cNvSpPr>
+          <ns0:nvPr/>
+        </ns0:nvSpPr>
+        <ns0:spPr>
+          <ns1:xfrm>
+            <ns1:off x="7810500" y="4000500"/>
+            <ns1:ext cx="76200" cy="1485900"/>
+          </ns1:xfrm>
+          <ns1:prstGeom prst="rect">
+            <ns1:avLst/>
+          </ns1:prstGeom>
+          <ns1:solidFill>
+            <ns1:srgbClr val="F4A261"/>
+          </ns1:solidFill>
+          <ns1:ln w="0">
+            <ns1:solidFill>
+              <ns1:srgbClr val="F4A261"/>
+            </ns1:solidFill>
+            <ns1:prstDash val="solid"/>
+          </ns1:ln>
+        </ns0:spPr>
+      </ns0:sp>
+      <ns0:sp>
+        <ns0:nvSpPr>
+          <ns0:cNvPr id="13" name="">
+            <ns1:extLst>
+              <ns1:ext uri="{FF2B5EF4-FFF2-40B4-BE49-F238E27FC236}">
+                <ns2:creationId id="{D4548902-7F7A-45BB-AA68-CB7E2EC852FB}"/>
+              </ns1:ext>
+            </ns1:extLst>
+          </ns0:cNvPr>
+          <ns0:cNvSpPr>
+            <ns1:spLocks noGrp="1"/>
+          </ns0:cNvSpPr>
+          <ns0:nvPr/>
+        </ns0:nvSpPr>
+        <ns0:spPr>
+          <ns1:xfrm>
+            <ns1:off x="8058150" y="4191000"/>
+            <ns1:ext cx="3371850" cy="361950"/>
+          </ns1:xfrm>
+          <ns1:prstGeom prst="rect">
+            <ns1:avLst/>
+          </ns1:prstGeom>
+          <ns1:noFill/>
+          <ns1:ln w="0">
+            <ns1:noFill/>
+            <ns1:prstDash val="solid"/>
+          </ns1:ln>
+        </ns0:spPr>
+        <ns0:txBody>
+          <ns1:bodyPr lIns="0" tIns="0" rIns="0" bIns="0" anchor="t">
+            <ns1:normAutofit fontScale="100000"/>
+          </ns1:bodyPr>
+          <ns1:lstStyle/>
+          <ns1:p>
+            <ns1:pPr>
+              <ns1:buNone/>
+              <ns1:defRPr sz="1725" b="1">
+                <ns1:solidFill>
+                  <ns1:srgbClr val="14213D"/>
+                </ns1:solidFill>
+                <ns1:latin typeface="Georgia"/>
+                <ns1:ea typeface="Georgia"/>
+                <ns1:cs typeface="Georgia"/>
+              </ns1:defRPr>
+            </ns1:pPr>
+            <ns1:r>
+              <ns1:rPr sz="1725" b="1">
+                <ns1:solidFill>
+                  <ns1:srgbClr val="14213D"/>
+                </ns1:solidFill>
+                <ns1:latin typeface="Georgia"/>
+                <ns1:ea typeface="Georgia"/>
+                <ns1:cs typeface="Georgia"/>
+              </ns1:rPr>
+              <ns1:t>MongoDB layer</ns1:t>
+            </ns1:r>
+          </ns1:p>
+        </ns0:txBody>
+      </ns0:sp>
+      <ns0:sp>
+        <ns0:nvSpPr>
+          <ns0:cNvPr id="14" name="">
+            <ns1:extLst>
+              <ns1:ext uri="{FF2B5EF4-FFF2-40B4-BE49-F238E27FC236}">
+                <ns2:creationId id="{E2801D96-4D9E-44A5-B7C6-661E9F9A05A9}"/>
+              </ns1:ext>
+            </ns1:extLst>
+          </ns0:cNvPr>
+          <ns0:cNvSpPr>
+            <ns1:spLocks noGrp="1"/>
+          </ns0:cNvSpPr>
+          <ns0:nvPr/>
+        </ns0:nvSpPr>
+        <ns0:spPr>
+          <ns1:xfrm>
+            <ns1:off x="8058150" y="4638675"/>
+            <ns1:ext cx="3371850" cy="647700"/>
+          </ns1:xfrm>
+          <ns1:prstGeom prst="rect">
+            <ns1:avLst/>
+          </ns1:prstGeom>
+          <ns1:noFill/>
+          <ns1:ln w="0">
+            <ns1:noFill/>
+            <ns1:prstDash val="solid"/>
+          </ns1:ln>
+        </ns0:spPr>
+        <ns0:txBody>
+          <ns1:bodyPr lIns="0" tIns="0" rIns="0" bIns="0" anchor="t">
+            <ns1:normAutofit fontScale="100000"/>
+          </ns1:bodyPr>
+          <ns1:lstStyle/>
+          <ns1:p>
+            <ns1:pPr>
+              <ns1:lnSpc>
+                <ns1:spcPct val="115000"/>
+              </ns1:lnSpc>
+              <ns1:buNone/>
+              <ns1:defRPr sz="1425">
+                <ns1:solidFill>
+                  <ns1:srgbClr val="5C6577"/>
+                </ns1:solidFill>
+                <ns1:latin typeface="Avenir Next"/>
+                <ns1:ea typeface="Avenir Next"/>
+                <ns1:cs typeface="Avenir Next"/>
+              </ns1:defRPr>
+            </ns1:pPr>
+            <ns1:r>
+              <ns1:rPr sz="1425">
+                <ns1:solidFill>
+                  <ns1:srgbClr val="5C6577"/>
+                </ns1:solidFill>
+                <ns1:latin typeface="Avenir Next"/>
+                <ns1:ea typeface="Avenir Next"/>
+                <ns1:cs typeface="Avenir Next"/>
+              </ns1:rPr>
+              <ns1:t>Databases · collections · BSON documents · queries · indexes</ns1:t>
+            </ns1:r>
+          </ns1:p>
+        </ns0:txBody>
+      </ns0:sp>
+      <ns0:sp>
+        <ns0:nvSpPr>
+          <ns0:cNvPr id="15" name="">
+            <ns1:extLst>
+              <ns1:ext uri="{FF2B5EF4-FFF2-40B4-BE49-F238E27FC236}">
+                <ns2:creationId id="{9A1E3507-E43F-4957-B019-5419EE166FAC}"/>
+              </ns1:ext>
+            </ns1:extLst>
+          </ns0:cNvPr>
+          <ns0:cNvSpPr>
+            <ns1:spLocks noGrp="1"/>
+          </ns0:cNvSpPr>
+          <ns0:nvPr/>
+        </ns0:nvSpPr>
+        <ns0:spPr>
+          <ns1:xfrm>
+            <ns1:off x="7943850" y="5772150"/>
+            <ns1:ext cx="3429000" cy="400050"/>
+          </ns1:xfrm>
+          <ns1:prstGeom prst="rect">
+            <ns1:avLst/>
+          </ns1:prstGeom>
+          <ns1:noFill/>
+          <ns1:ln w="0">
+            <ns1:noFill/>
+            <ns1:prstDash val="solid"/>
+          </ns1:ln>
+        </ns0:spPr>
+        <ns0:txBody>
+          <ns1:bodyPr wrap="square" lIns="0" tIns="0" rIns="0" bIns="0" anchor="t">
+            <ns1:noAutofit/>
+          </ns1:bodyPr>
+          <ns1:lstStyle/>
+          <ns1:p>
+            <ns1:pPr algn="ctr">
+              <ns1:buNone/>
+              <ns1:defRPr sz="1275" b="0">
+                <ns1:solidFill>
+                  <ns1:srgbClr val="5C6577"/>
+                </ns1:solidFill>
+                <ns1:latin typeface="Avenir Next"/>
+                <ns1:ea typeface="Avenir Next"/>
+                <ns1:cs typeface="Avenir Next"/>
+              </ns1:defRPr>
+            </ns1:pPr>
+            <ns1:r>
+              <ns1:rPr sz="1275" b="0">
+                <ns1:solidFill>
+                  <ns1:srgbClr val="5C6577"/>
+                </ns1:solidFill>
+                <ns1:latin typeface="Avenir Next"/>
+                <ns1:ea typeface="Avenir Next"/>
+                <ns1:cs typeface="Avenir Next"/>
+              </ns1:rPr>
+              <ns1:t>Dated interface example. No cloud account is needed for this week's lab.</ns1:t>
+            </ns1:r>
+          </ns1:p>
+        </ns0:txBody>
+      </ns0:sp>
+    </ns0:spTree>
+    <ns0:extLst>
+      <ns0:ext uri="{BB962C8B-B14F-4D97-AF65-F5344CB8AC3E}">
+        <ns4:creationId val="507522520"/>
+      </ns0:ext>
+    </ns0:extLst>
+  </ns0:cSld>
+</ns0:sld>
 </file>
 
 <file path=ppt/slides/slide7.xml><?xml version="1.0" encoding="utf-8"?>

</xml_diff>